<commit_message>
Sesion 2: edición manual de slides
Co-Authored-By: Claude Fable 5 <noreply@anthropic.com>
</commit_message>
<xml_diff>
--- a/curso/slides/Sesion_2_Preparacion_y_Carga.pptx
+++ b/curso/slides/Sesion_2_Preparacion_y_Carga.pptx
@@ -4,18 +4,21 @@
   <p:sldMasterIdLst>
     <p:sldMasterId id="2147483648" r:id="rId1"/>
   </p:sldMasterIdLst>
+  <p:notesMasterIdLst>
+    <p:notesMasterId r:id="rId11"/>
+  </p:notesMasterIdLst>
   <p:sldIdLst>
-    <p:sldId id="256" r:id="rId7"/>
-    <p:sldId id="257" r:id="rId9"/>
-    <p:sldId id="258" r:id="rId10"/>
-    <p:sldId id="259" r:id="rId11"/>
-    <p:sldId id="260" r:id="rId12"/>
-    <p:sldId id="261" r:id="rId13"/>
-    <p:sldId id="262" r:id="rId14"/>
-    <p:sldId id="263" r:id="rId15"/>
-    <p:sldId id="264" r:id="rId16"/>
+    <p:sldId id="256" r:id="rId2"/>
+    <p:sldId id="257" r:id="rId3"/>
+    <p:sldId id="258" r:id="rId4"/>
+    <p:sldId id="259" r:id="rId5"/>
+    <p:sldId id="260" r:id="rId6"/>
+    <p:sldId id="261" r:id="rId7"/>
+    <p:sldId id="262" r:id="rId8"/>
+    <p:sldId id="263" r:id="rId9"/>
+    <p:sldId id="264" r:id="rId10"/>
   </p:sldIdLst>
-  <p:sldSz cx="12191695" cy="6858000" type="screen4x3"/>
+  <p:sldSz cx="12192000" cy="6858000"/>
   <p:notesSz cx="6858000" cy="9144000"/>
   <p:defaultTextStyle>
     <a:defPPr>
@@ -112,11 +115,27 @@
       </a:defRPr>
     </a:lvl9pPr>
   </p:defaultTextStyle>
+  <p:extLst>
+    <p:ext uri="{EFAFB233-063F-42B5-8137-9DF3F51BA10A}">
+      <p15:sldGuideLst xmlns:p15="http://schemas.microsoft.com/office/powerpoint/2012/main">
+        <p15:guide id="1" orient="horz" pos="2160">
+          <p15:clr>
+            <a:srgbClr val="A4A3A4"/>
+          </p15:clr>
+        </p15:guide>
+        <p15:guide id="2" pos="2880">
+          <p15:clr>
+            <a:srgbClr val="A4A3A4"/>
+          </p15:clr>
+        </p15:guide>
+      </p15:sldGuideLst>
+    </p:ext>
+  </p:extLst>
 </p:presentation>
 </file>
 
 <file path=ppt/notesMasters/notesMaster1.xml><?xml version="1.0" encoding="utf-8"?>
-<p:notesMaster xmlns:a="http://schemas.openxmlformats.org/drawingml/2006/main" xmlns:p="http://schemas.openxmlformats.org/presentationml/2006/main" xmlns:r="http://schemas.openxmlformats.org/officeDocument/2006/relationships">
+<p:notesMaster xmlns:a="http://schemas.openxmlformats.org/drawingml/2006/main" xmlns:r="http://schemas.openxmlformats.org/officeDocument/2006/relationships" xmlns:p="http://schemas.openxmlformats.org/presentationml/2006/main">
   <p:cSld>
     <p:bg>
       <p:bgRef idx="1001">
@@ -137,241 +156,16 @@
           <a:chExt cx="0" cy="0"/>
         </a:xfrm>
       </p:grpSpPr>
-      <p:sp>
-        <p:nvSpPr>
-          <p:cNvPr id="2" name="Header Placeholder 1"/>
-          <p:cNvSpPr>
-            <a:spLocks noGrp="1"/>
-          </p:cNvSpPr>
-          <p:nvPr>
-            <p:ph type="hdr" sz="quarter"/>
-          </p:nvPr>
-        </p:nvSpPr>
-        <p:spPr>
-          <a:xfrm>
-            <a:off x="0" y="0"/>
-            <a:ext cx="2971800" cy="457200"/>
-          </a:xfrm>
-          <a:prstGeom prst="rect">
-            <a:avLst/>
-          </a:prstGeom>
-        </p:spPr>
-        <p:txBody>
-          <a:bodyPr vert="horz" lIns="91440" tIns="45720" rIns="91440" bIns="45720" rtlCol="0"/>
-          <a:lstStyle>
-            <a:lvl1pPr algn="l">
-              <a:defRPr sz="1200"/>
-            </a:lvl1pPr>
-          </a:lstStyle>
-          <a:p>
-            <a:endParaRPr lang="en-US"/>
-          </a:p>
-        </p:txBody>
-      </p:sp>
-      <p:sp>
-        <p:nvSpPr>
-          <p:cNvPr id="3" name="Date Placeholder 2"/>
-          <p:cNvSpPr>
-            <a:spLocks noGrp="1"/>
-          </p:cNvSpPr>
-          <p:nvPr>
-            <p:ph type="dt" idx="1"/>
-          </p:nvPr>
-        </p:nvSpPr>
-        <p:spPr>
-          <a:xfrm>
-            <a:off x="3884613" y="0"/>
-            <a:ext cx="2971800" cy="457200"/>
-          </a:xfrm>
-          <a:prstGeom prst="rect">
-            <a:avLst/>
-          </a:prstGeom>
-        </p:spPr>
-        <p:txBody>
-          <a:bodyPr vert="horz" lIns="91440" tIns="45720" rIns="91440" bIns="45720" rtlCol="0"/>
-          <a:lstStyle>
-            <a:lvl1pPr algn="r">
-              <a:defRPr sz="1200"/>
-            </a:lvl1pPr>
-          </a:lstStyle>
-          <a:p>
-            <a:fld id="{0F89C1C7-3DCD-1040-A9CF-14679D8B5DDD}" type="datetimeFigureOut">
-              <a:rPr lang="en-US" smtClean="0"/>
-              <a:t>10/17/16</a:t>
-            </a:fld>
-            <a:endParaRPr lang="en-US"/>
-          </a:p>
-        </p:txBody>
-      </p:sp>
-      <p:sp>
-        <p:nvSpPr>
-          <p:cNvPr id="4" name="Slide Image Placeholder 3"/>
-          <p:cNvSpPr>
-            <a:spLocks noGrp="1" noRot="1" noChangeAspect="1"/>
-          </p:cNvSpPr>
-          <p:nvPr>
-            <p:ph type="sldImg" idx="2"/>
-          </p:nvPr>
-        </p:nvSpPr>
-        <p:spPr>
-          <a:xfrm>
-            <a:off x="1143000" y="685800"/>
-            <a:ext cx="4572000" cy="3429000"/>
-          </a:xfrm>
-          <a:prstGeom prst="rect">
-            <a:avLst/>
-          </a:prstGeom>
-          <a:noFill/>
-          <a:ln w="12700">
-            <a:solidFill>
-              <a:prstClr val="black"/>
-            </a:solidFill>
-          </a:ln>
-        </p:spPr>
-        <p:txBody>
-          <a:bodyPr vert="horz" lIns="91440" tIns="45720" rIns="91440" bIns="45720" rtlCol="0" anchor="ctr"/>
-          <a:lstStyle/>
-          <a:p>
-            <a:endParaRPr lang="en-US"/>
-          </a:p>
-        </p:txBody>
-      </p:sp>
-      <p:sp>
-        <p:nvSpPr>
-          <p:cNvPr id="5" name="Notes Placeholder 4"/>
-          <p:cNvSpPr>
-            <a:spLocks noGrp="1"/>
-          </p:cNvSpPr>
-          <p:nvPr>
-            <p:ph type="body" sz="quarter" idx="3"/>
-          </p:nvPr>
-        </p:nvSpPr>
-        <p:spPr>
-          <a:xfrm>
-            <a:off x="685800" y="4343400"/>
-            <a:ext cx="5486400" cy="4114800"/>
-          </a:xfrm>
-          <a:prstGeom prst="rect">
-            <a:avLst/>
-          </a:prstGeom>
-        </p:spPr>
-        <p:txBody>
-          <a:bodyPr vert="horz" lIns="91440" tIns="45720" rIns="91440" bIns="45720" rtlCol="0"/>
-          <a:lstStyle/>
-          <a:p>
-            <a:pPr lvl="0"/>
-            <a:r>
-              <a:rPr lang="en-US" smtClean="0"/>
-              <a:t>Click to edit Master text styles</a:t>
-            </a:r>
-          </a:p>
-          <a:p>
-            <a:pPr lvl="1"/>
-            <a:r>
-              <a:rPr lang="en-US" smtClean="0"/>
-              <a:t>Second level</a:t>
-            </a:r>
-          </a:p>
-          <a:p>
-            <a:pPr lvl="2"/>
-            <a:r>
-              <a:rPr lang="en-US" smtClean="0"/>
-              <a:t>Third level</a:t>
-            </a:r>
-          </a:p>
-          <a:p>
-            <a:pPr lvl="3"/>
-            <a:r>
-              <a:rPr lang="en-US" smtClean="0"/>
-              <a:t>Fourth level</a:t>
-            </a:r>
-          </a:p>
-          <a:p>
-            <a:pPr lvl="4"/>
-            <a:r>
-              <a:rPr lang="en-US" smtClean="0"/>
-              <a:t>Fifth level</a:t>
-            </a:r>
-            <a:endParaRPr lang="en-US"/>
-          </a:p>
-        </p:txBody>
-      </p:sp>
-      <p:sp>
-        <p:nvSpPr>
-          <p:cNvPr id="6" name="Footer Placeholder 5"/>
-          <p:cNvSpPr>
-            <a:spLocks noGrp="1"/>
-          </p:cNvSpPr>
-          <p:nvPr>
-            <p:ph type="ftr" sz="quarter" idx="4"/>
-          </p:nvPr>
-        </p:nvSpPr>
-        <p:spPr>
-          <a:xfrm>
-            <a:off x="0" y="8685213"/>
-            <a:ext cx="2971800" cy="457200"/>
-          </a:xfrm>
-          <a:prstGeom prst="rect">
-            <a:avLst/>
-          </a:prstGeom>
-        </p:spPr>
-        <p:txBody>
-          <a:bodyPr vert="horz" lIns="91440" tIns="45720" rIns="91440" bIns="45720" rtlCol="0" anchor="b"/>
-          <a:lstStyle>
-            <a:lvl1pPr algn="l">
-              <a:defRPr sz="1200"/>
-            </a:lvl1pPr>
-          </a:lstStyle>
-          <a:p>
-            <a:endParaRPr lang="en-US"/>
-          </a:p>
-        </p:txBody>
-      </p:sp>
-      <p:sp>
-        <p:nvSpPr>
-          <p:cNvPr id="7" name="Slide Number Placeholder 6"/>
-          <p:cNvSpPr>
-            <a:spLocks noGrp="1"/>
-          </p:cNvSpPr>
-          <p:nvPr>
-            <p:ph type="sldNum" sz="quarter" idx="5"/>
-          </p:nvPr>
-        </p:nvSpPr>
-        <p:spPr>
-          <a:xfrm>
-            <a:off x="3884613" y="8685213"/>
-            <a:ext cx="2971800" cy="457200"/>
-          </a:xfrm>
-          <a:prstGeom prst="rect">
-            <a:avLst/>
-          </a:prstGeom>
-        </p:spPr>
-        <p:txBody>
-          <a:bodyPr vert="horz" lIns="91440" tIns="45720" rIns="91440" bIns="45720" rtlCol="0" anchor="b"/>
-          <a:lstStyle>
-            <a:lvl1pPr algn="r">
-              <a:defRPr sz="1200"/>
-            </a:lvl1pPr>
-          </a:lstStyle>
-          <a:p>
-            <a:fld id="{BB5E49A5-4136-284D-997B-48E1D791AD67}" type="slidenum">
-              <a:rPr lang="en-US" smtClean="0"/>
-              <a:t>‹#›</a:t>
-            </a:fld>
-            <a:endParaRPr lang="en-US"/>
-          </a:p>
-        </p:txBody>
-      </p:sp>
     </p:spTree>
     <p:extLst>
       <p:ext uri="{BB962C8B-B14F-4D97-AF65-F5344CB8AC3E}">
-        <p14:creationId xmlns:p14="http://schemas.microsoft.com/office/powerpoint/2010/main" val="2623252185"/>
+        <p14:creationId xmlns:p14="http://schemas.microsoft.com/office/powerpoint/2010/main" val="3476475471"/>
       </p:ext>
     </p:extLst>
   </p:cSld>
   <p:clrMap bg1="lt1" tx1="dk1" bg2="lt2" tx2="dk2" accent1="accent1" accent2="accent2" accent3="accent3" accent4="accent4" accent5="accent5" accent6="accent6" hlink="hlink" folHlink="folHlink"/>
   <p:notesStyle>
-    <a:lvl1pPr marL="0" algn="l" defTabSz="457200" rtl="0" eaLnBrk="1" latinLnBrk="0" hangingPunct="1">
+    <a:lvl1pPr marL="0" algn="l" defTabSz="914400" rtl="0" eaLnBrk="1" latinLnBrk="0" hangingPunct="1">
       <a:defRPr sz="1200" kern="1200">
         <a:solidFill>
           <a:schemeClr val="tx1"/>
@@ -381,7 +175,7 @@
         <a:cs typeface="+mn-cs"/>
       </a:defRPr>
     </a:lvl1pPr>
-    <a:lvl2pPr marL="457200" algn="l" defTabSz="457200" rtl="0" eaLnBrk="1" latinLnBrk="0" hangingPunct="1">
+    <a:lvl2pPr marL="457200" algn="l" defTabSz="914400" rtl="0" eaLnBrk="1" latinLnBrk="0" hangingPunct="1">
       <a:defRPr sz="1200" kern="1200">
         <a:solidFill>
           <a:schemeClr val="tx1"/>
@@ -391,7 +185,7 @@
         <a:cs typeface="+mn-cs"/>
       </a:defRPr>
     </a:lvl2pPr>
-    <a:lvl3pPr marL="914400" algn="l" defTabSz="457200" rtl="0" eaLnBrk="1" latinLnBrk="0" hangingPunct="1">
+    <a:lvl3pPr marL="914400" algn="l" defTabSz="914400" rtl="0" eaLnBrk="1" latinLnBrk="0" hangingPunct="1">
       <a:defRPr sz="1200" kern="1200">
         <a:solidFill>
           <a:schemeClr val="tx1"/>
@@ -401,7 +195,7 @@
         <a:cs typeface="+mn-cs"/>
       </a:defRPr>
     </a:lvl3pPr>
-    <a:lvl4pPr marL="1371600" algn="l" defTabSz="457200" rtl="0" eaLnBrk="1" latinLnBrk="0" hangingPunct="1">
+    <a:lvl4pPr marL="1371600" algn="l" defTabSz="914400" rtl="0" eaLnBrk="1" latinLnBrk="0" hangingPunct="1">
       <a:defRPr sz="1200" kern="1200">
         <a:solidFill>
           <a:schemeClr val="tx1"/>
@@ -411,7 +205,7 @@
         <a:cs typeface="+mn-cs"/>
       </a:defRPr>
     </a:lvl4pPr>
-    <a:lvl5pPr marL="1828800" algn="l" defTabSz="457200" rtl="0" eaLnBrk="1" latinLnBrk="0" hangingPunct="1">
+    <a:lvl5pPr marL="1828800" algn="l" defTabSz="914400" rtl="0" eaLnBrk="1" latinLnBrk="0" hangingPunct="1">
       <a:defRPr sz="1200" kern="1200">
         <a:solidFill>
           <a:schemeClr val="tx1"/>
@@ -421,7 +215,7 @@
         <a:cs typeface="+mn-cs"/>
       </a:defRPr>
     </a:lvl5pPr>
-    <a:lvl6pPr marL="2286000" algn="l" defTabSz="457200" rtl="0" eaLnBrk="1" latinLnBrk="0" hangingPunct="1">
+    <a:lvl6pPr marL="2286000" algn="l" defTabSz="914400" rtl="0" eaLnBrk="1" latinLnBrk="0" hangingPunct="1">
       <a:defRPr sz="1200" kern="1200">
         <a:solidFill>
           <a:schemeClr val="tx1"/>
@@ -431,7 +225,7 @@
         <a:cs typeface="+mn-cs"/>
       </a:defRPr>
     </a:lvl6pPr>
-    <a:lvl7pPr marL="2743200" algn="l" defTabSz="457200" rtl="0" eaLnBrk="1" latinLnBrk="0" hangingPunct="1">
+    <a:lvl7pPr marL="2743200" algn="l" defTabSz="914400" rtl="0" eaLnBrk="1" latinLnBrk="0" hangingPunct="1">
       <a:defRPr sz="1200" kern="1200">
         <a:solidFill>
           <a:schemeClr val="tx1"/>
@@ -441,7 +235,7 @@
         <a:cs typeface="+mn-cs"/>
       </a:defRPr>
     </a:lvl7pPr>
-    <a:lvl8pPr marL="3200400" algn="l" defTabSz="457200" rtl="0" eaLnBrk="1" latinLnBrk="0" hangingPunct="1">
+    <a:lvl8pPr marL="3200400" algn="l" defTabSz="914400" rtl="0" eaLnBrk="1" latinLnBrk="0" hangingPunct="1">
       <a:defRPr sz="1200" kern="1200">
         <a:solidFill>
           <a:schemeClr val="tx1"/>
@@ -451,7 +245,7 @@
         <a:cs typeface="+mn-cs"/>
       </a:defRPr>
     </a:lvl8pPr>
-    <a:lvl9pPr marL="3657600" algn="l" defTabSz="457200" rtl="0" eaLnBrk="1" latinLnBrk="0" hangingPunct="1">
+    <a:lvl9pPr marL="3657600" algn="l" defTabSz="914400" rtl="0" eaLnBrk="1" latinLnBrk="0" hangingPunct="1">
       <a:defRPr sz="1200" kern="1200">
         <a:solidFill>
           <a:schemeClr val="tx1"/>
@@ -466,7 +260,7 @@
 </file>
 
 <file path=ppt/notesSlides/notesSlide1.xml><?xml version="1.0" encoding="utf-8"?>
-<p:notes xmlns:a="http://schemas.openxmlformats.org/drawingml/2006/main" xmlns:p="http://schemas.openxmlformats.org/presentationml/2006/main" xmlns:r="http://schemas.openxmlformats.org/officeDocument/2006/relationships">
+<p:notes xmlns:a="http://schemas.openxmlformats.org/drawingml/2006/main" xmlns:r="http://schemas.openxmlformats.org/officeDocument/2006/relationships" xmlns:p="http://schemas.openxmlformats.org/presentationml/2006/main">
   <p:cSld>
     <p:spTree>
       <p:nvGrpSpPr>
@@ -486,43 +280,43 @@
         <p:nvSpPr>
           <p:cNvPr id="2" name="Slide Image Placeholder 1"/>
           <p:cNvSpPr>
+            <a:spLocks noGrp="1" noRot="1" noChangeAspect="1"/>
+          </p:cNvSpPr>
+          <p:nvPr>
+            <p:ph type="sldImg" idx="2"/>
+          </p:nvPr>
+        </p:nvSpPr>
+        <p:spPr/>
+      </p:sp>
+      <p:sp>
+        <p:nvSpPr>
+          <p:cNvPr id="3" name="Notes Placeholder 2"/>
+          <p:cNvSpPr>
             <a:spLocks noGrp="1"/>
           </p:cNvSpPr>
           <p:nvPr>
-            <p:ph type="sldImg" idx="2"/>
+            <p:ph type="body" sz="quarter" idx="3"/>
           </p:nvPr>
         </p:nvSpPr>
         <p:spPr/>
-      </p:sp>
-      <p:sp>
-        <p:nvSpPr>
-          <p:cNvPr id="3" name="Notes Placeholder 2"/>
+        <p:txBody>
+          <a:bodyPr/>
+          <a:lstStyle/>
+          <a:p>
+            <a:r>
+              <a:t>Respaldo: propuesta §4 + Capacitación Embeddings Parte 1-2 (solo ideas, sin código). Objetivo: que sepan dejar la biblioteca lista y entiendan por qué un documento 'entra mal'.</a:t>
+            </a:r>
+          </a:p>
+        </p:txBody>
+      </p:sp>
+      <p:sp>
+        <p:nvSpPr>
+          <p:cNvPr id="4" name="Slide Number Placeholder 3"/>
           <p:cNvSpPr>
             <a:spLocks noGrp="1"/>
           </p:cNvSpPr>
           <p:nvPr>
-            <p:ph type="body" idx="3" sz="quarter"/>
-          </p:nvPr>
-        </p:nvSpPr>
-        <p:spPr/>
-        <p:txBody>
-          <a:bodyPr/>
-          <a:lstStyle/>
-          <a:p>
-            <a:r>
-              <a:t>Respaldo: propuesta §4 + Capacitación Embeddings Parte 1-2 (solo ideas, sin código). Objetivo: que sepan dejar la biblioteca lista y entiendan por qué un documento 'entra mal'.</a:t>
-            </a:r>
-          </a:p>
-        </p:txBody>
-      </p:sp>
-      <p:sp>
-        <p:nvSpPr>
-          <p:cNvPr id="4" name="Slide Number Placeholder 3"/>
-          <p:cNvSpPr>
-            <a:spLocks noGrp="1"/>
-          </p:cNvSpPr>
-          <p:nvPr>
-            <p:ph type="sldNum" idx="5" sz="quarter"/>
+            <p:ph type="sldNum" sz="quarter" idx="5"/>
           </p:nvPr>
         </p:nvSpPr>
         <p:spPr/>
@@ -536,7 +330,7 @@
 </file>
 
 <file path=ppt/notesSlides/notesSlide2.xml><?xml version="1.0" encoding="utf-8"?>
-<p:notes xmlns:a="http://schemas.openxmlformats.org/drawingml/2006/main" xmlns:p="http://schemas.openxmlformats.org/presentationml/2006/main" xmlns:r="http://schemas.openxmlformats.org/officeDocument/2006/relationships">
+<p:notes xmlns:a="http://schemas.openxmlformats.org/drawingml/2006/main" xmlns:r="http://schemas.openxmlformats.org/officeDocument/2006/relationships" xmlns:p="http://schemas.openxmlformats.org/presentationml/2006/main">
   <p:cSld>
     <p:spTree>
       <p:nvGrpSpPr>
@@ -556,43 +350,43 @@
         <p:nvSpPr>
           <p:cNvPr id="2" name="Slide Image Placeholder 1"/>
           <p:cNvSpPr>
+            <a:spLocks noGrp="1" noRot="1" noChangeAspect="1"/>
+          </p:cNvSpPr>
+          <p:nvPr>
+            <p:ph type="sldImg" idx="2"/>
+          </p:nvPr>
+        </p:nvSpPr>
+        <p:spPr/>
+      </p:sp>
+      <p:sp>
+        <p:nvSpPr>
+          <p:cNvPr id="3" name="Notes Placeholder 2"/>
+          <p:cNvSpPr>
             <a:spLocks noGrp="1"/>
           </p:cNvSpPr>
           <p:nvPr>
-            <p:ph type="sldImg" idx="2"/>
+            <p:ph type="body" sz="quarter" idx="3"/>
           </p:nvPr>
         </p:nvSpPr>
         <p:spPr/>
-      </p:sp>
-      <p:sp>
-        <p:nvSpPr>
-          <p:cNvPr id="3" name="Notes Placeholder 2"/>
+        <p:txBody>
+          <a:bodyPr/>
+          <a:lstStyle/>
+          <a:p>
+            <a:r>
+              <a:t>Resolver dudas de semáforo con ejemplos concretos de su material.</a:t>
+            </a:r>
+          </a:p>
+        </p:txBody>
+      </p:sp>
+      <p:sp>
+        <p:nvSpPr>
+          <p:cNvPr id="4" name="Slide Number Placeholder 3"/>
           <p:cNvSpPr>
             <a:spLocks noGrp="1"/>
           </p:cNvSpPr>
           <p:nvPr>
-            <p:ph type="body" idx="3" sz="quarter"/>
-          </p:nvPr>
-        </p:nvSpPr>
-        <p:spPr/>
-        <p:txBody>
-          <a:bodyPr/>
-          <a:lstStyle/>
-          <a:p>
-            <a:r>
-              <a:t>Resolver dudas de semáforo con ejemplos concretos de su material.</a:t>
-            </a:r>
-          </a:p>
-        </p:txBody>
-      </p:sp>
-      <p:sp>
-        <p:nvSpPr>
-          <p:cNvPr id="4" name="Slide Number Placeholder 3"/>
-          <p:cNvSpPr>
-            <a:spLocks noGrp="1"/>
-          </p:cNvSpPr>
-          <p:nvPr>
-            <p:ph type="sldNum" idx="5" sz="quarter"/>
+            <p:ph type="sldNum" sz="quarter" idx="5"/>
           </p:nvPr>
         </p:nvSpPr>
         <p:spPr/>
@@ -606,7 +400,7 @@
 </file>
 
 <file path=ppt/notesSlides/notesSlide3.xml><?xml version="1.0" encoding="utf-8"?>
-<p:notes xmlns:a="http://schemas.openxmlformats.org/drawingml/2006/main" xmlns:p="http://schemas.openxmlformats.org/presentationml/2006/main" xmlns:r="http://schemas.openxmlformats.org/officeDocument/2006/relationships">
+<p:notes xmlns:a="http://schemas.openxmlformats.org/drawingml/2006/main" xmlns:r="http://schemas.openxmlformats.org/officeDocument/2006/relationships" xmlns:p="http://schemas.openxmlformats.org/presentationml/2006/main">
   <p:cSld>
     <p:spTree>
       <p:nvGrpSpPr>
@@ -626,43 +420,43 @@
         <p:nvSpPr>
           <p:cNvPr id="2" name="Slide Image Placeholder 1"/>
           <p:cNvSpPr>
+            <a:spLocks noGrp="1" noRot="1" noChangeAspect="1"/>
+          </p:cNvSpPr>
+          <p:nvPr>
+            <p:ph type="sldImg" idx="2"/>
+          </p:nvPr>
+        </p:nvSpPr>
+        <p:spPr/>
+      </p:sp>
+      <p:sp>
+        <p:nvSpPr>
+          <p:cNvPr id="3" name="Notes Placeholder 2"/>
+          <p:cNvSpPr>
             <a:spLocks noGrp="1"/>
           </p:cNvSpPr>
           <p:nvPr>
-            <p:ph type="sldImg" idx="2"/>
+            <p:ph type="body" sz="quarter" idx="3"/>
           </p:nvPr>
         </p:nvSpPr>
         <p:spPr/>
-      </p:sp>
-      <p:sp>
-        <p:nvSpPr>
-          <p:cNvPr id="3" name="Notes Placeholder 2"/>
+        <p:txBody>
+          <a:bodyPr/>
+          <a:lstStyle/>
+          <a:p>
+            <a:r>
+              <a:t>Truco para explicarlo: '¿pueden seleccionar el texto con el mouse? Entonces el asistente también puede leerlo. ¿No pueden? El asistente tampoco.'</a:t>
+            </a:r>
+          </a:p>
+        </p:txBody>
+      </p:sp>
+      <p:sp>
+        <p:nvSpPr>
+          <p:cNvPr id="4" name="Slide Number Placeholder 3"/>
           <p:cNvSpPr>
             <a:spLocks noGrp="1"/>
           </p:cNvSpPr>
           <p:nvPr>
-            <p:ph type="body" idx="3" sz="quarter"/>
-          </p:nvPr>
-        </p:nvSpPr>
-        <p:spPr/>
-        <p:txBody>
-          <a:bodyPr/>
-          <a:lstStyle/>
-          <a:p>
-            <a:r>
-              <a:t>Truco para explicarlo: '¿pueden seleccionar el texto con el mouse? Entonces el asistente también puede leerlo. ¿No pueden? El asistente tampoco.'</a:t>
-            </a:r>
-          </a:p>
-        </p:txBody>
-      </p:sp>
-      <p:sp>
-        <p:nvSpPr>
-          <p:cNvPr id="4" name="Slide Number Placeholder 3"/>
-          <p:cNvSpPr>
-            <a:spLocks noGrp="1"/>
-          </p:cNvSpPr>
-          <p:nvPr>
-            <p:ph type="sldNum" idx="5" sz="quarter"/>
+            <p:ph type="sldNum" sz="quarter" idx="5"/>
           </p:nvPr>
         </p:nvSpPr>
         <p:spPr/>
@@ -676,7 +470,7 @@
 </file>
 
 <file path=ppt/notesSlides/notesSlide4.xml><?xml version="1.0" encoding="utf-8"?>
-<p:notes xmlns:a="http://schemas.openxmlformats.org/drawingml/2006/main" xmlns:p="http://schemas.openxmlformats.org/presentationml/2006/main" xmlns:r="http://schemas.openxmlformats.org/officeDocument/2006/relationships">
+<p:notes xmlns:a="http://schemas.openxmlformats.org/drawingml/2006/main" xmlns:r="http://schemas.openxmlformats.org/officeDocument/2006/relationships" xmlns:p="http://schemas.openxmlformats.org/presentationml/2006/main">
   <p:cSld>
     <p:spTree>
       <p:nvGrpSpPr>
@@ -696,43 +490,204 @@
         <p:nvSpPr>
           <p:cNvPr id="2" name="Slide Image Placeholder 1"/>
           <p:cNvSpPr>
+            <a:spLocks noGrp="1" noRot="1" noChangeAspect="1"/>
+          </p:cNvSpPr>
+          <p:nvPr>
+            <p:ph type="sldImg" idx="2"/>
+          </p:nvPr>
+        </p:nvSpPr>
+        <p:spPr/>
+      </p:sp>
+      <p:sp>
+        <p:nvSpPr>
+          <p:cNvPr id="3" name="Notes Placeholder 2"/>
+          <p:cNvSpPr>
             <a:spLocks noGrp="1"/>
           </p:cNvSpPr>
           <p:nvPr>
-            <p:ph type="sldImg" idx="2"/>
+            <p:ph type="body" sz="quarter" idx="3"/>
           </p:nvPr>
         </p:nvSpPr>
         <p:spPr/>
-      </p:sp>
-      <p:sp>
-        <p:nvSpPr>
-          <p:cNvPr id="3" name="Notes Placeholder 2"/>
+        <p:txBody>
+          <a:bodyPr/>
+          <a:lstStyle/>
+          <a:p>
+            <a:r>
+              <a:rPr dirty="0"/>
+              <a:t>Demo con </a:t>
+            </a:r>
+            <a:r>
+              <a:rPr dirty="0" err="1"/>
+              <a:t>el</a:t>
+            </a:r>
+            <a:r>
+              <a:rPr dirty="0"/>
+              <a:t> </a:t>
+            </a:r>
+            <a:r>
+              <a:rPr dirty="0" err="1"/>
+              <a:t>escaneo</a:t>
+            </a:r>
+            <a:r>
+              <a:rPr dirty="0"/>
+              <a:t> </a:t>
+            </a:r>
+            <a:r>
+              <a:rPr dirty="0" err="1"/>
+              <a:t>simulado</a:t>
+            </a:r>
+            <a:r>
+              <a:rPr dirty="0"/>
+              <a:t> 2009 del sandbox: </a:t>
+            </a:r>
+            <a:r>
+              <a:rPr dirty="0" err="1"/>
+              <a:t>mostrar</a:t>
+            </a:r>
+            <a:r>
+              <a:rPr dirty="0"/>
+              <a:t> </a:t>
+            </a:r>
+            <a:r>
+              <a:rPr dirty="0" err="1"/>
+              <a:t>el</a:t>
+            </a:r>
+            <a:r>
+              <a:rPr dirty="0"/>
+              <a:t> PDF (</a:t>
+            </a:r>
+            <a:r>
+              <a:rPr dirty="0" err="1"/>
+              <a:t>texto</a:t>
+            </a:r>
+            <a:r>
+              <a:rPr dirty="0"/>
+              <a:t> no </a:t>
+            </a:r>
+            <a:r>
+              <a:rPr dirty="0" err="1"/>
+              <a:t>seleccionable</a:t>
+            </a:r>
+            <a:r>
+              <a:rPr dirty="0"/>
+              <a:t>) y la </a:t>
+            </a:r>
+            <a:r>
+              <a:rPr dirty="0" err="1"/>
+              <a:t>respuesta</a:t>
+            </a:r>
+            <a:r>
+              <a:rPr dirty="0"/>
+              <a:t> </a:t>
+            </a:r>
+            <a:r>
+              <a:rPr dirty="0" err="1"/>
+              <a:t>correcta</a:t>
+            </a:r>
+            <a:r>
+              <a:rPr dirty="0"/>
+              <a:t> (8,5% → 2,1%). </a:t>
+            </a:r>
+            <a:r>
+              <a:rPr dirty="0" err="1"/>
+              <a:t>Cerrar</a:t>
+            </a:r>
+            <a:r>
+              <a:rPr dirty="0"/>
+              <a:t> </a:t>
+            </a:r>
+            <a:r>
+              <a:rPr dirty="0" err="1"/>
+              <a:t>gestionando</a:t>
+            </a:r>
+            <a:r>
+              <a:rPr dirty="0"/>
+              <a:t> </a:t>
+            </a:r>
+            <a:r>
+              <a:rPr dirty="0" err="1"/>
+              <a:t>expectativa</a:t>
+            </a:r>
+            <a:r>
+              <a:rPr dirty="0"/>
+              <a:t>: </a:t>
+            </a:r>
+            <a:r>
+              <a:rPr dirty="0" err="1"/>
+              <a:t>los</a:t>
+            </a:r>
+            <a:r>
+              <a:rPr dirty="0"/>
+              <a:t> </a:t>
+            </a:r>
+            <a:r>
+              <a:rPr dirty="0" err="1"/>
+              <a:t>escaneos</a:t>
+            </a:r>
+            <a:r>
+              <a:rPr dirty="0"/>
+              <a:t> </a:t>
+            </a:r>
+            <a:r>
+              <a:rPr dirty="0" err="1"/>
+              <a:t>ilegibles</a:t>
+            </a:r>
+            <a:r>
+              <a:rPr dirty="0"/>
+              <a:t> de </a:t>
+            </a:r>
+            <a:r>
+              <a:rPr dirty="0" err="1"/>
+              <a:t>su</a:t>
+            </a:r>
+            <a:r>
+              <a:rPr dirty="0"/>
+              <a:t> </a:t>
+            </a:r>
+            <a:r>
+              <a:rPr dirty="0" err="1"/>
+              <a:t>archivo</a:t>
+            </a:r>
+            <a:r>
+              <a:rPr dirty="0"/>
+              <a:t> van a </a:t>
+            </a:r>
+            <a:r>
+              <a:rPr dirty="0" err="1"/>
+              <a:t>transcripción</a:t>
+            </a:r>
+            <a:r>
+              <a:rPr dirty="0"/>
+              <a:t> manual o </a:t>
+            </a:r>
+            <a:r>
+              <a:rPr dirty="0" err="1"/>
+              <a:t>segunda</a:t>
+            </a:r>
+            <a:r>
+              <a:rPr dirty="0"/>
+              <a:t> </a:t>
+            </a:r>
+            <a:r>
+              <a:rPr dirty="0" err="1"/>
+              <a:t>tanda</a:t>
+            </a:r>
+            <a:r>
+              <a:rPr dirty="0"/>
+              <a:t>.</a:t>
+            </a:r>
+          </a:p>
+        </p:txBody>
+      </p:sp>
+      <p:sp>
+        <p:nvSpPr>
+          <p:cNvPr id="4" name="Slide Number Placeholder 3"/>
           <p:cNvSpPr>
             <a:spLocks noGrp="1"/>
           </p:cNvSpPr>
           <p:nvPr>
-            <p:ph type="body" idx="3" sz="quarter"/>
-          </p:nvPr>
-        </p:nvSpPr>
-        <p:spPr/>
-        <p:txBody>
-          <a:bodyPr/>
-          <a:lstStyle/>
-          <a:p>
-            <a:r>
-              <a:t>Demo con el escaneo simulado 2009 del sandbox: mostrar el PDF (texto no seleccionable) y la respuesta correcta (8,5% → 2,1%). Cerrar gestionando expectativa: los escaneos ilegibles de su archivo van a transcripción manual o segunda tanda.</a:t>
-            </a:r>
-          </a:p>
-        </p:txBody>
-      </p:sp>
-      <p:sp>
-        <p:nvSpPr>
-          <p:cNvPr id="4" name="Slide Number Placeholder 3"/>
-          <p:cNvSpPr>
-            <a:spLocks noGrp="1"/>
-          </p:cNvSpPr>
-          <p:nvPr>
-            <p:ph type="sldNum" idx="5" sz="quarter"/>
+            <p:ph type="sldNum" sz="quarter" idx="5"/>
           </p:nvPr>
         </p:nvSpPr>
         <p:spPr/>
@@ -746,7 +701,7 @@
 </file>
 
 <file path=ppt/notesSlides/notesSlide5.xml><?xml version="1.0" encoding="utf-8"?>
-<p:notes xmlns:a="http://schemas.openxmlformats.org/drawingml/2006/main" xmlns:p="http://schemas.openxmlformats.org/presentationml/2006/main" xmlns:r="http://schemas.openxmlformats.org/officeDocument/2006/relationships">
+<p:notes xmlns:a="http://schemas.openxmlformats.org/drawingml/2006/main" xmlns:r="http://schemas.openxmlformats.org/officeDocument/2006/relationships" xmlns:p="http://schemas.openxmlformats.org/presentationml/2006/main">
   <p:cSld>
     <p:spTree>
       <p:nvGrpSpPr>
@@ -766,43 +721,43 @@
         <p:nvSpPr>
           <p:cNvPr id="2" name="Slide Image Placeholder 1"/>
           <p:cNvSpPr>
+            <a:spLocks noGrp="1" noRot="1" noChangeAspect="1"/>
+          </p:cNvSpPr>
+          <p:nvPr>
+            <p:ph type="sldImg" idx="2"/>
+          </p:nvPr>
+        </p:nvSpPr>
+        <p:spPr/>
+      </p:sp>
+      <p:sp>
+        <p:nvSpPr>
+          <p:cNvPr id="3" name="Notes Placeholder 2"/>
+          <p:cNvSpPr>
             <a:spLocks noGrp="1"/>
           </p:cNvSpPr>
           <p:nvPr>
-            <p:ph type="sldImg" idx="2"/>
+            <p:ph type="body" sz="quarter" idx="3"/>
           </p:nvPr>
         </p:nvSpPr>
         <p:spPr/>
-      </p:sp>
-      <p:sp>
-        <p:nvSpPr>
-          <p:cNvPr id="3" name="Notes Placeholder 2"/>
+        <p:txBody>
+          <a:bodyPr/>
+          <a:lstStyle/>
+          <a:p>
+            <a:r>
+              <a:t>Detalle técnico (no contar en clase): esto se implementa con la opción 'Documentos con metadatos (RAG)' del datastore — un JSONL que vincula metadatos a cada archivo del bucket; el esquema se detecta automático. Trabajo entre sesiones de Alejandro: script que lee cada documento, genera resumen + etiquetas con IA (análisis semántico), y arma el JSONL con lo validado en la planilla. ACLARACIÓN DE VOCABULARIO por si surge: esto NO es fine-tuning (no se reentrena ningún modelo); es enriquecimiento de datos — la palanca correcta y barata para mejorar un RAG gestionado.</a:t>
+            </a:r>
+          </a:p>
+        </p:txBody>
+      </p:sp>
+      <p:sp>
+        <p:nvSpPr>
+          <p:cNvPr id="4" name="Slide Number Placeholder 3"/>
           <p:cNvSpPr>
             <a:spLocks noGrp="1"/>
           </p:cNvSpPr>
           <p:nvPr>
-            <p:ph type="body" idx="3" sz="quarter"/>
-          </p:nvPr>
-        </p:nvSpPr>
-        <p:spPr/>
-        <p:txBody>
-          <a:bodyPr/>
-          <a:lstStyle/>
-          <a:p>
-            <a:r>
-              <a:t>Detalle técnico (no contar en clase): esto se implementa con la opción 'Documentos con metadatos (RAG)' del datastore — un JSONL que vincula metadatos a cada archivo del bucket; el esquema se detecta automático. Trabajo entre sesiones de Alejandro: script que lee cada documento, genera resumen + etiquetas con IA (análisis semántico), y arma el JSONL con lo validado en la planilla. ACLARACIÓN DE VOCABULARIO por si surge: esto NO es fine-tuning (no se reentrena ningún modelo); es enriquecimiento de datos — la palanca correcta y barata para mejorar un RAG gestionado.</a:t>
-            </a:r>
-          </a:p>
-        </p:txBody>
-      </p:sp>
-      <p:sp>
-        <p:nvSpPr>
-          <p:cNvPr id="4" name="Slide Number Placeholder 3"/>
-          <p:cNvSpPr>
-            <a:spLocks noGrp="1"/>
-          </p:cNvSpPr>
-          <p:nvPr>
-            <p:ph type="sldNum" idx="5" sz="quarter"/>
+            <p:ph type="sldNum" sz="quarter" idx="5"/>
           </p:nvPr>
         </p:nvSpPr>
         <p:spPr/>
@@ -816,7 +771,7 @@
 </file>
 
 <file path=ppt/notesSlides/notesSlide6.xml><?xml version="1.0" encoding="utf-8"?>
-<p:notes xmlns:a="http://schemas.openxmlformats.org/drawingml/2006/main" xmlns:p="http://schemas.openxmlformats.org/presentationml/2006/main" xmlns:r="http://schemas.openxmlformats.org/officeDocument/2006/relationships">
+<p:notes xmlns:a="http://schemas.openxmlformats.org/drawingml/2006/main" xmlns:r="http://schemas.openxmlformats.org/officeDocument/2006/relationships" xmlns:p="http://schemas.openxmlformats.org/presentationml/2006/main">
   <p:cSld>
     <p:spTree>
       <p:nvGrpSpPr>
@@ -836,43 +791,43 @@
         <p:nvSpPr>
           <p:cNvPr id="2" name="Slide Image Placeholder 1"/>
           <p:cNvSpPr>
+            <a:spLocks noGrp="1" noRot="1" noChangeAspect="1"/>
+          </p:cNvSpPr>
+          <p:nvPr>
+            <p:ph type="sldImg" idx="2"/>
+          </p:nvPr>
+        </p:nvSpPr>
+        <p:spPr/>
+      </p:sp>
+      <p:sp>
+        <p:nvSpPr>
+          <p:cNvPr id="3" name="Notes Placeholder 2"/>
+          <p:cNvSpPr>
             <a:spLocks noGrp="1"/>
           </p:cNvSpPr>
           <p:nvPr>
-            <p:ph type="sldImg" idx="2"/>
+            <p:ph type="body" sz="quarter" idx="3"/>
           </p:nvPr>
         </p:nvSpPr>
         <p:spPr/>
-      </p:sp>
-      <p:sp>
-        <p:nvSpPr>
-          <p:cNvPr id="3" name="Notes Placeholder 2"/>
+        <p:txBody>
+          <a:bodyPr/>
+          <a:lstStyle/>
+          <a:p>
+            <a:r>
+              <a:t>Acá empieza la transferencia. Plan B obligatorio: si la indexación se demora, mostrar el sandbox propio mientras tanto. Nunca cargar por primera vez en vivo sin red de seguridad.</a:t>
+            </a:r>
+          </a:p>
+        </p:txBody>
+      </p:sp>
+      <p:sp>
+        <p:nvSpPr>
+          <p:cNvPr id="4" name="Slide Number Placeholder 3"/>
           <p:cNvSpPr>
             <a:spLocks noGrp="1"/>
           </p:cNvSpPr>
           <p:nvPr>
-            <p:ph type="body" idx="3" sz="quarter"/>
-          </p:nvPr>
-        </p:nvSpPr>
-        <p:spPr/>
-        <p:txBody>
-          <a:bodyPr/>
-          <a:lstStyle/>
-          <a:p>
-            <a:r>
-              <a:t>Acá empieza la transferencia. Plan B obligatorio: si la indexación se demora, mostrar el sandbox propio mientras tanto. Nunca cargar por primera vez en vivo sin red de seguridad.</a:t>
-            </a:r>
-          </a:p>
-        </p:txBody>
-      </p:sp>
-      <p:sp>
-        <p:nvSpPr>
-          <p:cNvPr id="4" name="Slide Number Placeholder 3"/>
-          <p:cNvSpPr>
-            <a:spLocks noGrp="1"/>
-          </p:cNvSpPr>
-          <p:nvPr>
-            <p:ph type="sldNum" idx="5" sz="quarter"/>
+            <p:ph type="sldNum" sz="quarter" idx="5"/>
           </p:nvPr>
         </p:nvSpPr>
         <p:spPr/>
@@ -886,7 +841,7 @@
 </file>
 
 <file path=ppt/notesSlides/notesSlide7.xml><?xml version="1.0" encoding="utf-8"?>
-<p:notes xmlns:a="http://schemas.openxmlformats.org/drawingml/2006/main" xmlns:p="http://schemas.openxmlformats.org/presentationml/2006/main" xmlns:r="http://schemas.openxmlformats.org/officeDocument/2006/relationships">
+<p:notes xmlns:a="http://schemas.openxmlformats.org/drawingml/2006/main" xmlns:r="http://schemas.openxmlformats.org/officeDocument/2006/relationships" xmlns:p="http://schemas.openxmlformats.org/presentationml/2006/main">
   <p:cSld>
     <p:spTree>
       <p:nvGrpSpPr>
@@ -906,43 +861,43 @@
         <p:nvSpPr>
           <p:cNvPr id="2" name="Slide Image Placeholder 1"/>
           <p:cNvSpPr>
+            <a:spLocks noGrp="1" noRot="1" noChangeAspect="1"/>
+          </p:cNvSpPr>
+          <p:nvPr>
+            <p:ph type="sldImg" idx="2"/>
+          </p:nvPr>
+        </p:nvSpPr>
+        <p:spPr/>
+      </p:sp>
+      <p:sp>
+        <p:nvSpPr>
+          <p:cNvPr id="3" name="Notes Placeholder 2"/>
+          <p:cNvSpPr>
             <a:spLocks noGrp="1"/>
           </p:cNvSpPr>
           <p:nvPr>
-            <p:ph type="sldImg" idx="2"/>
+            <p:ph type="body" sz="quarter" idx="3"/>
           </p:nvPr>
         </p:nvSpPr>
         <p:spPr/>
-      </p:sp>
-      <p:sp>
-        <p:nvSpPr>
-          <p:cNvPr id="3" name="Notes Placeholder 2"/>
+        <p:txBody>
+          <a:bodyPr/>
+          <a:lstStyle/>
+          <a:p>
+            <a:r>
+              <a:t>Ensayarlo COMPLETO una vez en vivo y cronometrar: ese número responde la futura pregunta '¿cuándo aparece lo que subo?'. Este procedimiento va al manual de operación de la Sesión 4.</a:t>
+            </a:r>
+          </a:p>
+        </p:txBody>
+      </p:sp>
+      <p:sp>
+        <p:nvSpPr>
+          <p:cNvPr id="4" name="Slide Number Placeholder 3"/>
           <p:cNvSpPr>
             <a:spLocks noGrp="1"/>
           </p:cNvSpPr>
           <p:nvPr>
-            <p:ph type="body" idx="3" sz="quarter"/>
-          </p:nvPr>
-        </p:nvSpPr>
-        <p:spPr/>
-        <p:txBody>
-          <a:bodyPr/>
-          <a:lstStyle/>
-          <a:p>
-            <a:r>
-              <a:t>Ensayarlo COMPLETO una vez en vivo y cronometrar: ese número responde la futura pregunta '¿cuándo aparece lo que subo?'. Este procedimiento va al manual de operación de la Sesión 4.</a:t>
-            </a:r>
-          </a:p>
-        </p:txBody>
-      </p:sp>
-      <p:sp>
-        <p:nvSpPr>
-          <p:cNvPr id="4" name="Slide Number Placeholder 3"/>
-          <p:cNvSpPr>
-            <a:spLocks noGrp="1"/>
-          </p:cNvSpPr>
-          <p:nvPr>
-            <p:ph type="sldNum" idx="5" sz="quarter"/>
+            <p:ph type="sldNum" sz="quarter" idx="5"/>
           </p:nvPr>
         </p:nvSpPr>
         <p:spPr/>
@@ -956,7 +911,7 @@
 </file>
 
 <file path=ppt/notesSlides/notesSlide8.xml><?xml version="1.0" encoding="utf-8"?>
-<p:notes xmlns:a="http://schemas.openxmlformats.org/drawingml/2006/main" xmlns:p="http://schemas.openxmlformats.org/presentationml/2006/main" xmlns:r="http://schemas.openxmlformats.org/officeDocument/2006/relationships">
+<p:notes xmlns:a="http://schemas.openxmlformats.org/drawingml/2006/main" xmlns:r="http://schemas.openxmlformats.org/officeDocument/2006/relationships" xmlns:p="http://schemas.openxmlformats.org/presentationml/2006/main">
   <p:cSld>
     <p:spTree>
       <p:nvGrpSpPr>
@@ -976,43 +931,43 @@
         <p:nvSpPr>
           <p:cNvPr id="2" name="Slide Image Placeholder 1"/>
           <p:cNvSpPr>
+            <a:spLocks noGrp="1" noRot="1" noChangeAspect="1"/>
+          </p:cNvSpPr>
+          <p:nvPr>
+            <p:ph type="sldImg" idx="2"/>
+          </p:nvPr>
+        </p:nvSpPr>
+        <p:spPr/>
+      </p:sp>
+      <p:sp>
+        <p:nvSpPr>
+          <p:cNvPr id="3" name="Notes Placeholder 2"/>
+          <p:cNvSpPr>
             <a:spLocks noGrp="1"/>
           </p:cNvSpPr>
           <p:nvPr>
-            <p:ph type="sldImg" idx="2"/>
+            <p:ph type="body" sz="quarter" idx="3"/>
           </p:nvPr>
         </p:nvSpPr>
         <p:spPr/>
-      </p:sp>
-      <p:sp>
-        <p:nvSpPr>
-          <p:cNvPr id="3" name="Notes Placeholder 2"/>
+        <p:txBody>
+          <a:bodyPr/>
+          <a:lstStyle/>
+          <a:p>
+            <a:r>
+              <a:t>Entre sesiones: OCR/descripciones del material difícil, completar indexación y crear la app conectada a los 2 datastores.</a:t>
+            </a:r>
+          </a:p>
+        </p:txBody>
+      </p:sp>
+      <p:sp>
+        <p:nvSpPr>
+          <p:cNvPr id="4" name="Slide Number Placeholder 3"/>
           <p:cNvSpPr>
             <a:spLocks noGrp="1"/>
           </p:cNvSpPr>
           <p:nvPr>
-            <p:ph type="body" idx="3" sz="quarter"/>
-          </p:nvPr>
-        </p:nvSpPr>
-        <p:spPr/>
-        <p:txBody>
-          <a:bodyPr/>
-          <a:lstStyle/>
-          <a:p>
-            <a:r>
-              <a:t>Entre sesiones: OCR/descripciones del material difícil, completar indexación y crear la app conectada a los 2 datastores.</a:t>
-            </a:r>
-          </a:p>
-        </p:txBody>
-      </p:sp>
-      <p:sp>
-        <p:nvSpPr>
-          <p:cNvPr id="4" name="Slide Number Placeholder 3"/>
-          <p:cNvSpPr>
-            <a:spLocks noGrp="1"/>
-          </p:cNvSpPr>
-          <p:nvPr>
-            <p:ph type="sldNum" idx="5" sz="quarter"/>
+            <p:ph type="sldNum" sz="quarter" idx="5"/>
           </p:nvPr>
         </p:nvSpPr>
         <p:spPr/>
@@ -1063,10 +1018,9 @@
           <a:lstStyle/>
           <a:p>
             <a:r>
-              <a:rPr lang="en-US" smtClean="0"/>
+              <a:rPr lang="en-US"/>
               <a:t>Click to edit Master title style</a:t>
             </a:r>
-            <a:endParaRPr lang="en-US"/>
           </a:p>
         </p:txBody>
       </p:sp>
@@ -1182,10 +1136,9 @@
           </a:lstStyle>
           <a:p>
             <a:r>
-              <a:rPr lang="en-US" smtClean="0"/>
+              <a:rPr lang="en-US"/>
               <a:t>Click to edit Master subtitle style</a:t>
             </a:r>
-            <a:endParaRPr lang="en-US"/>
           </a:p>
         </p:txBody>
       </p:sp>
@@ -1206,7 +1159,7 @@
           <a:p>
             <a:fld id="{5BCAD085-E8A6-8845-BD4E-CB4CCA059FC4}" type="datetimeFigureOut">
               <a:rPr lang="en-US" smtClean="0"/>
-              <a:t>1/27/13</a:t>
+              <a:t>8/19/26</a:t>
             </a:fld>
             <a:endParaRPr lang="en-US"/>
           </a:p>
@@ -1248,7 +1201,7 @@
           <a:p>
             <a:fld id="{C1FF6DA9-008F-8B48-92A6-B652298478BF}" type="slidenum">
               <a:rPr lang="en-US" smtClean="0"/>
-              <a:t>‹#›</a:t>
+              <a:t>‹N°›</a:t>
             </a:fld>
             <a:endParaRPr lang="en-US"/>
           </a:p>
@@ -1300,10 +1253,9 @@
           <a:lstStyle/>
           <a:p>
             <a:r>
-              <a:rPr lang="en-US" smtClean="0"/>
+              <a:rPr lang="en-US"/>
               <a:t>Click to edit Master title style</a:t>
             </a:r>
-            <a:endParaRPr lang="en-US"/>
           </a:p>
         </p:txBody>
       </p:sp>
@@ -1324,38 +1276,37 @@
           <a:p>
             <a:pPr lvl="0"/>
             <a:r>
-              <a:rPr lang="en-US" smtClean="0"/>
+              <a:rPr lang="en-US"/>
               <a:t>Click to edit Master text styles</a:t>
             </a:r>
           </a:p>
           <a:p>
             <a:pPr lvl="1"/>
             <a:r>
-              <a:rPr lang="en-US" smtClean="0"/>
+              <a:rPr lang="en-US"/>
               <a:t>Second level</a:t>
             </a:r>
           </a:p>
           <a:p>
             <a:pPr lvl="2"/>
             <a:r>
-              <a:rPr lang="en-US" smtClean="0"/>
+              <a:rPr lang="en-US"/>
               <a:t>Third level</a:t>
             </a:r>
           </a:p>
           <a:p>
             <a:pPr lvl="3"/>
             <a:r>
-              <a:rPr lang="en-US" smtClean="0"/>
+              <a:rPr lang="en-US"/>
               <a:t>Fourth level</a:t>
             </a:r>
           </a:p>
           <a:p>
             <a:pPr lvl="4"/>
             <a:r>
-              <a:rPr lang="en-US" smtClean="0"/>
+              <a:rPr lang="en-US"/>
               <a:t>Fifth level</a:t>
             </a:r>
-            <a:endParaRPr lang="en-US"/>
           </a:p>
         </p:txBody>
       </p:sp>
@@ -1376,7 +1327,7 @@
           <a:p>
             <a:fld id="{5BCAD085-E8A6-8845-BD4E-CB4CCA059FC4}" type="datetimeFigureOut">
               <a:rPr lang="en-US" smtClean="0"/>
-              <a:t>1/27/13</a:t>
+              <a:t>8/19/26</a:t>
             </a:fld>
             <a:endParaRPr lang="en-US"/>
           </a:p>
@@ -1418,7 +1369,7 @@
           <a:p>
             <a:fld id="{C1FF6DA9-008F-8B48-92A6-B652298478BF}" type="slidenum">
               <a:rPr lang="en-US" smtClean="0"/>
-              <a:t>‹#›</a:t>
+              <a:t>‹N°›</a:t>
             </a:fld>
             <a:endParaRPr lang="en-US"/>
           </a:p>
@@ -1475,10 +1426,9 @@
           <a:lstStyle/>
           <a:p>
             <a:r>
-              <a:rPr lang="en-US" smtClean="0"/>
+              <a:rPr lang="en-US"/>
               <a:t>Click to edit Master title style</a:t>
             </a:r>
-            <a:endParaRPr lang="en-US"/>
           </a:p>
         </p:txBody>
       </p:sp>
@@ -1504,38 +1454,37 @@
           <a:p>
             <a:pPr lvl="0"/>
             <a:r>
-              <a:rPr lang="en-US" smtClean="0"/>
+              <a:rPr lang="en-US"/>
               <a:t>Click to edit Master text styles</a:t>
             </a:r>
           </a:p>
           <a:p>
             <a:pPr lvl="1"/>
             <a:r>
-              <a:rPr lang="en-US" smtClean="0"/>
+              <a:rPr lang="en-US"/>
               <a:t>Second level</a:t>
             </a:r>
           </a:p>
           <a:p>
             <a:pPr lvl="2"/>
             <a:r>
-              <a:rPr lang="en-US" smtClean="0"/>
+              <a:rPr lang="en-US"/>
               <a:t>Third level</a:t>
             </a:r>
           </a:p>
           <a:p>
             <a:pPr lvl="3"/>
             <a:r>
-              <a:rPr lang="en-US" smtClean="0"/>
+              <a:rPr lang="en-US"/>
               <a:t>Fourth level</a:t>
             </a:r>
           </a:p>
           <a:p>
             <a:pPr lvl="4"/>
             <a:r>
-              <a:rPr lang="en-US" smtClean="0"/>
+              <a:rPr lang="en-US"/>
               <a:t>Fifth level</a:t>
             </a:r>
-            <a:endParaRPr lang="en-US"/>
           </a:p>
         </p:txBody>
       </p:sp>
@@ -1556,7 +1505,7 @@
           <a:p>
             <a:fld id="{5BCAD085-E8A6-8845-BD4E-CB4CCA059FC4}" type="datetimeFigureOut">
               <a:rPr lang="en-US" smtClean="0"/>
-              <a:t>1/27/13</a:t>
+              <a:t>8/19/26</a:t>
             </a:fld>
             <a:endParaRPr lang="en-US"/>
           </a:p>
@@ -1598,7 +1547,7 @@
           <a:p>
             <a:fld id="{C1FF6DA9-008F-8B48-92A6-B652298478BF}" type="slidenum">
               <a:rPr lang="en-US" smtClean="0"/>
-              <a:t>‹#›</a:t>
+              <a:t>‹N°›</a:t>
             </a:fld>
             <a:endParaRPr lang="en-US"/>
           </a:p>
@@ -1650,10 +1599,9 @@
           <a:lstStyle/>
           <a:p>
             <a:r>
-              <a:rPr lang="en-US" smtClean="0"/>
+              <a:rPr lang="en-US"/>
               <a:t>Click to edit Master title style</a:t>
             </a:r>
-            <a:endParaRPr lang="en-US"/>
           </a:p>
         </p:txBody>
       </p:sp>
@@ -1674,38 +1622,37 @@
           <a:p>
             <a:pPr lvl="0"/>
             <a:r>
-              <a:rPr lang="en-US" smtClean="0"/>
+              <a:rPr lang="en-US"/>
               <a:t>Click to edit Master text styles</a:t>
             </a:r>
           </a:p>
           <a:p>
             <a:pPr lvl="1"/>
             <a:r>
-              <a:rPr lang="en-US" smtClean="0"/>
+              <a:rPr lang="en-US"/>
               <a:t>Second level</a:t>
             </a:r>
           </a:p>
           <a:p>
             <a:pPr lvl="2"/>
             <a:r>
-              <a:rPr lang="en-US" smtClean="0"/>
+              <a:rPr lang="en-US"/>
               <a:t>Third level</a:t>
             </a:r>
           </a:p>
           <a:p>
             <a:pPr lvl="3"/>
             <a:r>
-              <a:rPr lang="en-US" smtClean="0"/>
+              <a:rPr lang="en-US"/>
               <a:t>Fourth level</a:t>
             </a:r>
           </a:p>
           <a:p>
             <a:pPr lvl="4"/>
             <a:r>
-              <a:rPr lang="en-US" smtClean="0"/>
+              <a:rPr lang="en-US"/>
               <a:t>Fifth level</a:t>
             </a:r>
-            <a:endParaRPr lang="en-US"/>
           </a:p>
         </p:txBody>
       </p:sp>
@@ -1726,7 +1673,7 @@
           <a:p>
             <a:fld id="{5BCAD085-E8A6-8845-BD4E-CB4CCA059FC4}" type="datetimeFigureOut">
               <a:rPr lang="en-US" smtClean="0"/>
-              <a:t>1/27/13</a:t>
+              <a:t>8/19/26</a:t>
             </a:fld>
             <a:endParaRPr lang="en-US"/>
           </a:p>
@@ -1768,7 +1715,7 @@
           <a:p>
             <a:fld id="{C1FF6DA9-008F-8B48-92A6-B652298478BF}" type="slidenum">
               <a:rPr lang="en-US" smtClean="0"/>
-              <a:t>‹#›</a:t>
+              <a:t>‹N°›</a:t>
             </a:fld>
             <a:endParaRPr lang="en-US"/>
           </a:p>
@@ -1829,10 +1776,9 @@
           </a:lstStyle>
           <a:p>
             <a:r>
-              <a:rPr lang="en-US" smtClean="0"/>
+              <a:rPr lang="en-US"/>
               <a:t>Click to edit Master title style</a:t>
             </a:r>
-            <a:endParaRPr lang="en-US"/>
           </a:p>
         </p:txBody>
       </p:sp>
@@ -1949,7 +1895,7 @@
           <a:p>
             <a:pPr lvl="0"/>
             <a:r>
-              <a:rPr lang="en-US" smtClean="0"/>
+              <a:rPr lang="en-US"/>
               <a:t>Click to edit Master text styles</a:t>
             </a:r>
           </a:p>
@@ -1972,7 +1918,7 @@
           <a:p>
             <a:fld id="{5BCAD085-E8A6-8845-BD4E-CB4CCA059FC4}" type="datetimeFigureOut">
               <a:rPr lang="en-US" smtClean="0"/>
-              <a:t>1/27/13</a:t>
+              <a:t>8/19/26</a:t>
             </a:fld>
             <a:endParaRPr lang="en-US"/>
           </a:p>
@@ -2014,7 +1960,7 @@
           <a:p>
             <a:fld id="{C1FF6DA9-008F-8B48-92A6-B652298478BF}" type="slidenum">
               <a:rPr lang="en-US" smtClean="0"/>
-              <a:t>‹#›</a:t>
+              <a:t>‹N°›</a:t>
             </a:fld>
             <a:endParaRPr lang="en-US"/>
           </a:p>
@@ -2066,10 +2012,9 @@
           <a:lstStyle/>
           <a:p>
             <a:r>
-              <a:rPr lang="en-US" smtClean="0"/>
+              <a:rPr lang="en-US"/>
               <a:t>Click to edit Master title style</a:t>
             </a:r>
-            <a:endParaRPr lang="en-US"/>
           </a:p>
         </p:txBody>
       </p:sp>
@@ -2123,38 +2068,37 @@
           <a:p>
             <a:pPr lvl="0"/>
             <a:r>
-              <a:rPr lang="en-US" smtClean="0"/>
+              <a:rPr lang="en-US"/>
               <a:t>Click to edit Master text styles</a:t>
             </a:r>
           </a:p>
           <a:p>
             <a:pPr lvl="1"/>
             <a:r>
-              <a:rPr lang="en-US" smtClean="0"/>
+              <a:rPr lang="en-US"/>
               <a:t>Second level</a:t>
             </a:r>
           </a:p>
           <a:p>
             <a:pPr lvl="2"/>
             <a:r>
-              <a:rPr lang="en-US" smtClean="0"/>
+              <a:rPr lang="en-US"/>
               <a:t>Third level</a:t>
             </a:r>
           </a:p>
           <a:p>
             <a:pPr lvl="3"/>
             <a:r>
-              <a:rPr lang="en-US" smtClean="0"/>
+              <a:rPr lang="en-US"/>
               <a:t>Fourth level</a:t>
             </a:r>
           </a:p>
           <a:p>
             <a:pPr lvl="4"/>
             <a:r>
-              <a:rPr lang="en-US" smtClean="0"/>
+              <a:rPr lang="en-US"/>
               <a:t>Fifth level</a:t>
             </a:r>
-            <a:endParaRPr lang="en-US"/>
           </a:p>
         </p:txBody>
       </p:sp>
@@ -2208,38 +2152,37 @@
           <a:p>
             <a:pPr lvl="0"/>
             <a:r>
-              <a:rPr lang="en-US" smtClean="0"/>
+              <a:rPr lang="en-US"/>
               <a:t>Click to edit Master text styles</a:t>
             </a:r>
           </a:p>
           <a:p>
             <a:pPr lvl="1"/>
             <a:r>
-              <a:rPr lang="en-US" smtClean="0"/>
+              <a:rPr lang="en-US"/>
               <a:t>Second level</a:t>
             </a:r>
           </a:p>
           <a:p>
             <a:pPr lvl="2"/>
             <a:r>
-              <a:rPr lang="en-US" smtClean="0"/>
+              <a:rPr lang="en-US"/>
               <a:t>Third level</a:t>
             </a:r>
           </a:p>
           <a:p>
             <a:pPr lvl="3"/>
             <a:r>
-              <a:rPr lang="en-US" smtClean="0"/>
+              <a:rPr lang="en-US"/>
               <a:t>Fourth level</a:t>
             </a:r>
           </a:p>
           <a:p>
             <a:pPr lvl="4"/>
             <a:r>
-              <a:rPr lang="en-US" smtClean="0"/>
+              <a:rPr lang="en-US"/>
               <a:t>Fifth level</a:t>
             </a:r>
-            <a:endParaRPr lang="en-US"/>
           </a:p>
         </p:txBody>
       </p:sp>
@@ -2260,7 +2203,7 @@
           <a:p>
             <a:fld id="{5BCAD085-E8A6-8845-BD4E-CB4CCA059FC4}" type="datetimeFigureOut">
               <a:rPr lang="en-US" smtClean="0"/>
-              <a:t>1/27/13</a:t>
+              <a:t>8/19/26</a:t>
             </a:fld>
             <a:endParaRPr lang="en-US"/>
           </a:p>
@@ -2302,7 +2245,7 @@
           <a:p>
             <a:fld id="{C1FF6DA9-008F-8B48-92A6-B652298478BF}" type="slidenum">
               <a:rPr lang="en-US" smtClean="0"/>
-              <a:t>‹#›</a:t>
+              <a:t>‹N°›</a:t>
             </a:fld>
             <a:endParaRPr lang="en-US"/>
           </a:p>
@@ -2358,10 +2301,9 @@
           </a:lstStyle>
           <a:p>
             <a:r>
-              <a:rPr lang="en-US" smtClean="0"/>
+              <a:rPr lang="en-US"/>
               <a:t>Click to edit Master title style</a:t>
             </a:r>
-            <a:endParaRPr lang="en-US"/>
           </a:p>
         </p:txBody>
       </p:sp>
@@ -2424,7 +2366,7 @@
           <a:p>
             <a:pPr lvl="0"/>
             <a:r>
-              <a:rPr lang="en-US" smtClean="0"/>
+              <a:rPr lang="en-US"/>
               <a:t>Click to edit Master text styles</a:t>
             </a:r>
           </a:p>
@@ -2480,38 +2422,37 @@
           <a:p>
             <a:pPr lvl="0"/>
             <a:r>
-              <a:rPr lang="en-US" smtClean="0"/>
+              <a:rPr lang="en-US"/>
               <a:t>Click to edit Master text styles</a:t>
             </a:r>
           </a:p>
           <a:p>
             <a:pPr lvl="1"/>
             <a:r>
-              <a:rPr lang="en-US" smtClean="0"/>
+              <a:rPr lang="en-US"/>
               <a:t>Second level</a:t>
             </a:r>
           </a:p>
           <a:p>
             <a:pPr lvl="2"/>
             <a:r>
-              <a:rPr lang="en-US" smtClean="0"/>
+              <a:rPr lang="en-US"/>
               <a:t>Third level</a:t>
             </a:r>
           </a:p>
           <a:p>
             <a:pPr lvl="3"/>
             <a:r>
-              <a:rPr lang="en-US" smtClean="0"/>
+              <a:rPr lang="en-US"/>
               <a:t>Fourth level</a:t>
             </a:r>
           </a:p>
           <a:p>
             <a:pPr lvl="4"/>
             <a:r>
-              <a:rPr lang="en-US" smtClean="0"/>
+              <a:rPr lang="en-US"/>
               <a:t>Fifth level</a:t>
             </a:r>
-            <a:endParaRPr lang="en-US"/>
           </a:p>
         </p:txBody>
       </p:sp>
@@ -2574,7 +2515,7 @@
           <a:p>
             <a:pPr lvl="0"/>
             <a:r>
-              <a:rPr lang="en-US" smtClean="0"/>
+              <a:rPr lang="en-US"/>
               <a:t>Click to edit Master text styles</a:t>
             </a:r>
           </a:p>
@@ -2630,38 +2571,37 @@
           <a:p>
             <a:pPr lvl="0"/>
             <a:r>
-              <a:rPr lang="en-US" smtClean="0"/>
+              <a:rPr lang="en-US"/>
               <a:t>Click to edit Master text styles</a:t>
             </a:r>
           </a:p>
           <a:p>
             <a:pPr lvl="1"/>
             <a:r>
-              <a:rPr lang="en-US" smtClean="0"/>
+              <a:rPr lang="en-US"/>
               <a:t>Second level</a:t>
             </a:r>
           </a:p>
           <a:p>
             <a:pPr lvl="2"/>
             <a:r>
-              <a:rPr lang="en-US" smtClean="0"/>
+              <a:rPr lang="en-US"/>
               <a:t>Third level</a:t>
             </a:r>
           </a:p>
           <a:p>
             <a:pPr lvl="3"/>
             <a:r>
-              <a:rPr lang="en-US" smtClean="0"/>
+              <a:rPr lang="en-US"/>
               <a:t>Fourth level</a:t>
             </a:r>
           </a:p>
           <a:p>
             <a:pPr lvl="4"/>
             <a:r>
-              <a:rPr lang="en-US" smtClean="0"/>
+              <a:rPr lang="en-US"/>
               <a:t>Fifth level</a:t>
             </a:r>
-            <a:endParaRPr lang="en-US"/>
           </a:p>
         </p:txBody>
       </p:sp>
@@ -2682,7 +2622,7 @@
           <a:p>
             <a:fld id="{5BCAD085-E8A6-8845-BD4E-CB4CCA059FC4}" type="datetimeFigureOut">
               <a:rPr lang="en-US" smtClean="0"/>
-              <a:t>1/27/13</a:t>
+              <a:t>8/19/26</a:t>
             </a:fld>
             <a:endParaRPr lang="en-US"/>
           </a:p>
@@ -2724,7 +2664,7 @@
           <a:p>
             <a:fld id="{C1FF6DA9-008F-8B48-92A6-B652298478BF}" type="slidenum">
               <a:rPr lang="en-US" smtClean="0"/>
-              <a:t>‹#›</a:t>
+              <a:t>‹N°›</a:t>
             </a:fld>
             <a:endParaRPr lang="en-US"/>
           </a:p>
@@ -2776,10 +2716,9 @@
           <a:lstStyle/>
           <a:p>
             <a:r>
-              <a:rPr lang="en-US" smtClean="0"/>
+              <a:rPr lang="en-US"/>
               <a:t>Click to edit Master title style</a:t>
             </a:r>
-            <a:endParaRPr lang="en-US"/>
           </a:p>
         </p:txBody>
       </p:sp>
@@ -2800,7 +2739,7 @@
           <a:p>
             <a:fld id="{5BCAD085-E8A6-8845-BD4E-CB4CCA059FC4}" type="datetimeFigureOut">
               <a:rPr lang="en-US" smtClean="0"/>
-              <a:t>1/27/13</a:t>
+              <a:t>8/19/26</a:t>
             </a:fld>
             <a:endParaRPr lang="en-US"/>
           </a:p>
@@ -2842,7 +2781,7 @@
           <a:p>
             <a:fld id="{C1FF6DA9-008F-8B48-92A6-B652298478BF}" type="slidenum">
               <a:rPr lang="en-US" smtClean="0"/>
-              <a:t>‹#›</a:t>
+              <a:t>‹N°›</a:t>
             </a:fld>
             <a:endParaRPr lang="en-US"/>
           </a:p>
@@ -2895,7 +2834,7 @@
           <a:p>
             <a:fld id="{5BCAD085-E8A6-8845-BD4E-CB4CCA059FC4}" type="datetimeFigureOut">
               <a:rPr lang="en-US" smtClean="0"/>
-              <a:t>1/27/13</a:t>
+              <a:t>8/19/26</a:t>
             </a:fld>
             <a:endParaRPr lang="en-US"/>
           </a:p>
@@ -2937,7 +2876,7 @@
           <a:p>
             <a:fld id="{C1FF6DA9-008F-8B48-92A6-B652298478BF}" type="slidenum">
               <a:rPr lang="en-US" smtClean="0"/>
-              <a:t>‹#›</a:t>
+              <a:t>‹N°›</a:t>
             </a:fld>
             <a:endParaRPr lang="en-US"/>
           </a:p>
@@ -2998,10 +2937,9 @@
           </a:lstStyle>
           <a:p>
             <a:r>
-              <a:rPr lang="en-US" smtClean="0"/>
+              <a:rPr lang="en-US"/>
               <a:t>Click to edit Master title style</a:t>
             </a:r>
-            <a:endParaRPr lang="en-US"/>
           </a:p>
         </p:txBody>
       </p:sp>
@@ -3055,38 +2993,37 @@
           <a:p>
             <a:pPr lvl="0"/>
             <a:r>
-              <a:rPr lang="en-US" smtClean="0"/>
+              <a:rPr lang="en-US"/>
               <a:t>Click to edit Master text styles</a:t>
             </a:r>
           </a:p>
           <a:p>
             <a:pPr lvl="1"/>
             <a:r>
-              <a:rPr lang="en-US" smtClean="0"/>
+              <a:rPr lang="en-US"/>
               <a:t>Second level</a:t>
             </a:r>
           </a:p>
           <a:p>
             <a:pPr lvl="2"/>
             <a:r>
-              <a:rPr lang="en-US" smtClean="0"/>
+              <a:rPr lang="en-US"/>
               <a:t>Third level</a:t>
             </a:r>
           </a:p>
           <a:p>
             <a:pPr lvl="3"/>
             <a:r>
-              <a:rPr lang="en-US" smtClean="0"/>
+              <a:rPr lang="en-US"/>
               <a:t>Fourth level</a:t>
             </a:r>
           </a:p>
           <a:p>
             <a:pPr lvl="4"/>
             <a:r>
-              <a:rPr lang="en-US" smtClean="0"/>
+              <a:rPr lang="en-US"/>
               <a:t>Fifth level</a:t>
             </a:r>
-            <a:endParaRPr lang="en-US"/>
           </a:p>
         </p:txBody>
       </p:sp>
@@ -3149,7 +3086,7 @@
           <a:p>
             <a:pPr lvl="0"/>
             <a:r>
-              <a:rPr lang="en-US" smtClean="0"/>
+              <a:rPr lang="en-US"/>
               <a:t>Click to edit Master text styles</a:t>
             </a:r>
           </a:p>
@@ -3172,7 +3109,7 @@
           <a:p>
             <a:fld id="{5BCAD085-E8A6-8845-BD4E-CB4CCA059FC4}" type="datetimeFigureOut">
               <a:rPr lang="en-US" smtClean="0"/>
-              <a:t>1/27/13</a:t>
+              <a:t>8/19/26</a:t>
             </a:fld>
             <a:endParaRPr lang="en-US"/>
           </a:p>
@@ -3214,7 +3151,7 @@
           <a:p>
             <a:fld id="{C1FF6DA9-008F-8B48-92A6-B652298478BF}" type="slidenum">
               <a:rPr lang="en-US" smtClean="0"/>
-              <a:t>‹#›</a:t>
+              <a:t>‹N°›</a:t>
             </a:fld>
             <a:endParaRPr lang="en-US"/>
           </a:p>
@@ -3275,10 +3212,9 @@
           </a:lstStyle>
           <a:p>
             <a:r>
-              <a:rPr lang="en-US" smtClean="0"/>
+              <a:rPr lang="en-US"/>
               <a:t>Click to edit Master title style</a:t>
             </a:r>
-            <a:endParaRPr lang="en-US"/>
           </a:p>
         </p:txBody>
       </p:sp>
@@ -3402,7 +3338,7 @@
           <a:p>
             <a:pPr lvl="0"/>
             <a:r>
-              <a:rPr lang="en-US" smtClean="0"/>
+              <a:rPr lang="en-US"/>
               <a:t>Click to edit Master text styles</a:t>
             </a:r>
           </a:p>
@@ -3425,7 +3361,7 @@
           <a:p>
             <a:fld id="{5BCAD085-E8A6-8845-BD4E-CB4CCA059FC4}" type="datetimeFigureOut">
               <a:rPr lang="en-US" smtClean="0"/>
-              <a:t>1/27/13</a:t>
+              <a:t>8/19/26</a:t>
             </a:fld>
             <a:endParaRPr lang="en-US"/>
           </a:p>
@@ -3467,7 +3403,7 @@
           <a:p>
             <a:fld id="{C1FF6DA9-008F-8B48-92A6-B652298478BF}" type="slidenum">
               <a:rPr lang="en-US" smtClean="0"/>
-              <a:t>‹#›</a:t>
+              <a:t>‹N°›</a:t>
             </a:fld>
             <a:endParaRPr lang="en-US"/>
           </a:p>
@@ -3534,10 +3470,9 @@
           <a:lstStyle/>
           <a:p>
             <a:r>
-              <a:rPr lang="en-US" smtClean="0"/>
+              <a:rPr lang="en-US"/>
               <a:t>Click to edit Master title style</a:t>
             </a:r>
-            <a:endParaRPr lang="en-US"/>
           </a:p>
         </p:txBody>
       </p:sp>
@@ -3568,38 +3503,37 @@
           <a:p>
             <a:pPr lvl="0"/>
             <a:r>
-              <a:rPr lang="en-US" smtClean="0"/>
+              <a:rPr lang="en-US"/>
               <a:t>Click to edit Master text styles</a:t>
             </a:r>
           </a:p>
           <a:p>
             <a:pPr lvl="1"/>
             <a:r>
-              <a:rPr lang="en-US" smtClean="0"/>
+              <a:rPr lang="en-US"/>
               <a:t>Second level</a:t>
             </a:r>
           </a:p>
           <a:p>
             <a:pPr lvl="2"/>
             <a:r>
-              <a:rPr lang="en-US" smtClean="0"/>
+              <a:rPr lang="en-US"/>
               <a:t>Third level</a:t>
             </a:r>
           </a:p>
           <a:p>
             <a:pPr lvl="3"/>
             <a:r>
-              <a:rPr lang="en-US" smtClean="0"/>
+              <a:rPr lang="en-US"/>
               <a:t>Fourth level</a:t>
             </a:r>
           </a:p>
           <a:p>
             <a:pPr lvl="4"/>
             <a:r>
-              <a:rPr lang="en-US" smtClean="0"/>
+              <a:rPr lang="en-US"/>
               <a:t>Fifth level</a:t>
             </a:r>
-            <a:endParaRPr lang="en-US"/>
           </a:p>
         </p:txBody>
       </p:sp>
@@ -3638,7 +3572,7 @@
           <a:p>
             <a:fld id="{5BCAD085-E8A6-8845-BD4E-CB4CCA059FC4}" type="datetimeFigureOut">
               <a:rPr lang="en-US" smtClean="0"/>
-              <a:t>1/27/13</a:t>
+              <a:t>8/19/26</a:t>
             </a:fld>
             <a:endParaRPr lang="en-US"/>
           </a:p>
@@ -3716,7 +3650,7 @@
           <a:p>
             <a:fld id="{C1FF6DA9-008F-8B48-92A6-B652298478BF}" type="slidenum">
               <a:rPr lang="en-US" smtClean="0"/>
-              <a:t>‹#›</a:t>
+              <a:t>‹N°›</a:t>
             </a:fld>
             <a:endParaRPr lang="en-US"/>
           </a:p>
@@ -3997,7 +3931,7 @@
 </file>
 
 <file path=ppt/slides/slide1.xml><?xml version="1.0" encoding="utf-8"?>
-<p:sld xmlns:a="http://schemas.openxmlformats.org/drawingml/2006/main" xmlns:p="http://schemas.openxmlformats.org/presentationml/2006/main" xmlns:r="http://schemas.openxmlformats.org/officeDocument/2006/relationships">
+<p:sld xmlns:a="http://schemas.openxmlformats.org/drawingml/2006/main" xmlns:r="http://schemas.openxmlformats.org/officeDocument/2006/relationships" xmlns:p="http://schemas.openxmlformats.org/presentationml/2006/main">
   <p:cSld>
     <p:spTree>
       <p:nvGrpSpPr>
@@ -4005,7 +3939,14 @@
         <p:cNvGrpSpPr/>
         <p:nvPr/>
       </p:nvGrpSpPr>
-      <p:grpSpPr/>
+      <p:grpSpPr>
+        <a:xfrm>
+          <a:off x="0" y="0"/>
+          <a:ext cx="0" cy="0"/>
+          <a:chOff x="0" y="0"/>
+          <a:chExt cx="0" cy="0"/>
+        </a:xfrm>
+      </p:grpSpPr>
       <p:sp>
         <p:nvSpPr>
           <p:cNvPr id="2" name="Rectangle 1"/>
@@ -4046,6 +3987,7 @@
           <a:lstStyle/>
           <a:p>
             <a:pPr algn="ctr"/>
+            <a:endParaRPr/>
           </a:p>
         </p:txBody>
       </p:sp>
@@ -4089,6 +4031,7 @@
           <a:lstStyle/>
           <a:p>
             <a:pPr algn="ctr"/>
+            <a:endParaRPr/>
           </a:p>
         </p:txBody>
       </p:sp>
@@ -4230,7 +4173,7 @@
 </file>
 
 <file path=ppt/slides/slide2.xml><?xml version="1.0" encoding="utf-8"?>
-<p:sld xmlns:a="http://schemas.openxmlformats.org/drawingml/2006/main" xmlns:p="http://schemas.openxmlformats.org/presentationml/2006/main" xmlns:r="http://schemas.openxmlformats.org/officeDocument/2006/relationships">
+<p:sld xmlns:a="http://schemas.openxmlformats.org/drawingml/2006/main" xmlns:r="http://schemas.openxmlformats.org/officeDocument/2006/relationships" xmlns:p="http://schemas.openxmlformats.org/presentationml/2006/main">
   <p:cSld>
     <p:spTree>
       <p:nvGrpSpPr>
@@ -4238,7 +4181,14 @@
         <p:cNvGrpSpPr/>
         <p:nvPr/>
       </p:nvGrpSpPr>
-      <p:grpSpPr/>
+      <p:grpSpPr>
+        <a:xfrm>
+          <a:off x="0" y="0"/>
+          <a:ext cx="0" cy="0"/>
+          <a:chOff x="0" y="0"/>
+          <a:chExt cx="0" cy="0"/>
+        </a:xfrm>
+      </p:grpSpPr>
       <p:sp>
         <p:nvSpPr>
           <p:cNvPr id="2" name="Rectangle 1"/>
@@ -4279,6 +4229,7 @@
           <a:lstStyle/>
           <a:p>
             <a:pPr algn="ctr"/>
+            <a:endParaRPr/>
           </a:p>
         </p:txBody>
       </p:sp>
@@ -4360,15 +4311,29 @@
                 <a:tableStyleId>{5C22544A-7EE6-4342-B048-85BDC9FD1C3A}</a:tableStyleId>
               </a:tblPr>
               <a:tblGrid>
-                <a:gridCol w="1371600"/>
-                <a:gridCol w="9098280"/>
+                <a:gridCol w="1371600">
+                  <a:extLst>
+                    <a:ext uri="{9D8B030D-6E8A-4147-A177-3AD203B41FA5}">
+                      <a16:colId xmlns:a16="http://schemas.microsoft.com/office/drawing/2014/main" val="20000"/>
+                    </a:ext>
+                  </a:extLst>
+                </a:gridCol>
+                <a:gridCol w="9098280">
+                  <a:extLst>
+                    <a:ext uri="{9D8B030D-6E8A-4147-A177-3AD203B41FA5}">
+                      <a16:colId xmlns:a16="http://schemas.microsoft.com/office/drawing/2014/main" val="20001"/>
+                    </a:ext>
+                  </a:extLst>
+                </a:gridCol>
               </a:tblGrid>
               <a:tr h="548640">
                 <a:tc>
                   <a:txBody>
                     <a:bodyPr/>
                     <a:lstStyle/>
-                    <a:p/>
+                    <a:p>
+                      <a:endParaRPr/>
+                    </a:p>
                   </a:txBody>
                   <a:tcPr>
                     <a:solidFill>
@@ -4398,6 +4363,11 @@
                     </a:solidFill>
                   </a:tcPr>
                 </a:tc>
+                <a:extLst>
+                  <a:ext uri="{0D108BD9-81ED-4DB2-BD59-A6C34878D82A}">
+                    <a16:rowId xmlns:a16="http://schemas.microsoft.com/office/drawing/2014/main" val="10000"/>
+                  </a:ext>
+                </a:extLst>
               </a:tr>
               <a:tr h="548640">
                 <a:tc>
@@ -4444,6 +4414,11 @@
                     </a:solidFill>
                   </a:tcPr>
                 </a:tc>
+                <a:extLst>
+                  <a:ext uri="{0D108BD9-81ED-4DB2-BD59-A6C34878D82A}">
+                    <a16:rowId xmlns:a16="http://schemas.microsoft.com/office/drawing/2014/main" val="10001"/>
+                  </a:ext>
+                </a:extLst>
               </a:tr>
               <a:tr h="548640">
                 <a:tc>
@@ -4490,6 +4465,11 @@
                     </a:solidFill>
                   </a:tcPr>
                 </a:tc>
+                <a:extLst>
+                  <a:ext uri="{0D108BD9-81ED-4DB2-BD59-A6C34878D82A}">
+                    <a16:rowId xmlns:a16="http://schemas.microsoft.com/office/drawing/2014/main" val="10002"/>
+                  </a:ext>
+                </a:extLst>
               </a:tr>
               <a:tr h="548640">
                 <a:tc>
@@ -4536,6 +4516,11 @@
                     </a:solidFill>
                   </a:tcPr>
                 </a:tc>
+                <a:extLst>
+                  <a:ext uri="{0D108BD9-81ED-4DB2-BD59-A6C34878D82A}">
+                    <a16:rowId xmlns:a16="http://schemas.microsoft.com/office/drawing/2014/main" val="10003"/>
+                  </a:ext>
+                </a:extLst>
               </a:tr>
               <a:tr h="548640">
                 <a:tc>
@@ -4582,6 +4567,11 @@
                     </a:solidFill>
                   </a:tcPr>
                 </a:tc>
+                <a:extLst>
+                  <a:ext uri="{0D108BD9-81ED-4DB2-BD59-A6C34878D82A}">
+                    <a16:rowId xmlns:a16="http://schemas.microsoft.com/office/drawing/2014/main" val="10004"/>
+                  </a:ext>
+                </a:extLst>
               </a:tr>
               <a:tr h="548640">
                 <a:tc>
@@ -4628,6 +4618,11 @@
                     </a:solidFill>
                   </a:tcPr>
                 </a:tc>
+                <a:extLst>
+                  <a:ext uri="{0D108BD9-81ED-4DB2-BD59-A6C34878D82A}">
+                    <a16:rowId xmlns:a16="http://schemas.microsoft.com/office/drawing/2014/main" val="10005"/>
+                  </a:ext>
+                </a:extLst>
               </a:tr>
             </a:tbl>
           </a:graphicData>
@@ -4642,7 +4637,7 @@
 </file>
 
 <file path=ppt/slides/slide3.xml><?xml version="1.0" encoding="utf-8"?>
-<p:sld xmlns:a="http://schemas.openxmlformats.org/drawingml/2006/main" xmlns:p="http://schemas.openxmlformats.org/presentationml/2006/main" xmlns:r="http://schemas.openxmlformats.org/officeDocument/2006/relationships">
+<p:sld xmlns:a="http://schemas.openxmlformats.org/drawingml/2006/main" xmlns:r="http://schemas.openxmlformats.org/officeDocument/2006/relationships" xmlns:p="http://schemas.openxmlformats.org/presentationml/2006/main">
   <p:cSld>
     <p:spTree>
       <p:nvGrpSpPr>
@@ -4650,7 +4645,14 @@
         <p:cNvGrpSpPr/>
         <p:nvPr/>
       </p:nvGrpSpPr>
-      <p:grpSpPr/>
+      <p:grpSpPr>
+        <a:xfrm>
+          <a:off x="0" y="0"/>
+          <a:ext cx="0" cy="0"/>
+          <a:chOff x="0" y="0"/>
+          <a:chExt cx="0" cy="0"/>
+        </a:xfrm>
+      </p:grpSpPr>
       <p:sp>
         <p:nvSpPr>
           <p:cNvPr id="2" name="Rectangle 1"/>
@@ -4691,6 +4693,7 @@
           <a:lstStyle/>
           <a:p>
             <a:pPr algn="ctr"/>
+            <a:endParaRPr/>
           </a:p>
         </p:txBody>
       </p:sp>
@@ -4868,7 +4871,7 @@
 </file>
 
 <file path=ppt/slides/slide4.xml><?xml version="1.0" encoding="utf-8"?>
-<p:sld xmlns:a="http://schemas.openxmlformats.org/drawingml/2006/main" xmlns:p="http://schemas.openxmlformats.org/presentationml/2006/main" xmlns:r="http://schemas.openxmlformats.org/officeDocument/2006/relationships">
+<p:sld xmlns:a="http://schemas.openxmlformats.org/drawingml/2006/main" xmlns:r="http://schemas.openxmlformats.org/officeDocument/2006/relationships" xmlns:p="http://schemas.openxmlformats.org/presentationml/2006/main">
   <p:cSld>
     <p:spTree>
       <p:nvGrpSpPr>
@@ -4876,7 +4879,14 @@
         <p:cNvGrpSpPr/>
         <p:nvPr/>
       </p:nvGrpSpPr>
-      <p:grpSpPr/>
+      <p:grpSpPr>
+        <a:xfrm>
+          <a:off x="0" y="0"/>
+          <a:ext cx="0" cy="0"/>
+          <a:chOff x="0" y="0"/>
+          <a:chExt cx="0" cy="0"/>
+        </a:xfrm>
+      </p:grpSpPr>
       <p:sp>
         <p:nvSpPr>
           <p:cNvPr id="2" name="Rectangle 1"/>
@@ -4917,6 +4927,7 @@
           <a:lstStyle/>
           <a:p>
             <a:pPr algn="ctr"/>
+            <a:endParaRPr/>
           </a:p>
         </p:txBody>
       </p:sp>
@@ -5033,8 +5044,20 @@
                 <a:tableStyleId>{5C22544A-7EE6-4342-B048-85BDC9FD1C3A}</a:tableStyleId>
               </a:tblPr>
               <a:tblGrid>
-                <a:gridCol w="3566160"/>
-                <a:gridCol w="6903720"/>
+                <a:gridCol w="3566160">
+                  <a:extLst>
+                    <a:ext uri="{9D8B030D-6E8A-4147-A177-3AD203B41FA5}">
+                      <a16:colId xmlns:a16="http://schemas.microsoft.com/office/drawing/2014/main" val="20000"/>
+                    </a:ext>
+                  </a:extLst>
+                </a:gridCol>
+                <a:gridCol w="6903720">
+                  <a:extLst>
+                    <a:ext uri="{9D8B030D-6E8A-4147-A177-3AD203B41FA5}">
+                      <a16:colId xmlns:a16="http://schemas.microsoft.com/office/drawing/2014/main" val="20001"/>
+                    </a:ext>
+                  </a:extLst>
+                </a:gridCol>
               </a:tblGrid>
               <a:tr h="557784">
                 <a:tc>
@@ -5081,6 +5104,11 @@
                     </a:solidFill>
                   </a:tcPr>
                 </a:tc>
+                <a:extLst>
+                  <a:ext uri="{0D108BD9-81ED-4DB2-BD59-A6C34878D82A}">
+                    <a16:rowId xmlns:a16="http://schemas.microsoft.com/office/drawing/2014/main" val="10000"/>
+                  </a:ext>
+                </a:extLst>
               </a:tr>
               <a:tr h="557784">
                 <a:tc>
@@ -5127,6 +5155,11 @@
                     </a:solidFill>
                   </a:tcPr>
                 </a:tc>
+                <a:extLst>
+                  <a:ext uri="{0D108BD9-81ED-4DB2-BD59-A6C34878D82A}">
+                    <a16:rowId xmlns:a16="http://schemas.microsoft.com/office/drawing/2014/main" val="10001"/>
+                  </a:ext>
+                </a:extLst>
               </a:tr>
               <a:tr h="557784">
                 <a:tc>
@@ -5173,6 +5206,11 @@
                     </a:solidFill>
                   </a:tcPr>
                 </a:tc>
+                <a:extLst>
+                  <a:ext uri="{0D108BD9-81ED-4DB2-BD59-A6C34878D82A}">
+                    <a16:rowId xmlns:a16="http://schemas.microsoft.com/office/drawing/2014/main" val="10002"/>
+                  </a:ext>
+                </a:extLst>
               </a:tr>
               <a:tr h="557784">
                 <a:tc>
@@ -5219,6 +5257,11 @@
                     </a:solidFill>
                   </a:tcPr>
                 </a:tc>
+                <a:extLst>
+                  <a:ext uri="{0D108BD9-81ED-4DB2-BD59-A6C34878D82A}">
+                    <a16:rowId xmlns:a16="http://schemas.microsoft.com/office/drawing/2014/main" val="10003"/>
+                  </a:ext>
+                </a:extLst>
               </a:tr>
               <a:tr h="557784">
                 <a:tc>
@@ -5265,6 +5308,11 @@
                     </a:solidFill>
                   </a:tcPr>
                 </a:tc>
+                <a:extLst>
+                  <a:ext uri="{0D108BD9-81ED-4DB2-BD59-A6C34878D82A}">
+                    <a16:rowId xmlns:a16="http://schemas.microsoft.com/office/drawing/2014/main" val="10004"/>
+                  </a:ext>
+                </a:extLst>
               </a:tr>
             </a:tbl>
           </a:graphicData>
@@ -5279,7 +5327,7 @@
 </file>
 
 <file path=ppt/slides/slide5.xml><?xml version="1.0" encoding="utf-8"?>
-<p:sld xmlns:a="http://schemas.openxmlformats.org/drawingml/2006/main" xmlns:p="http://schemas.openxmlformats.org/presentationml/2006/main" xmlns:r="http://schemas.openxmlformats.org/officeDocument/2006/relationships">
+<p:sld xmlns:a="http://schemas.openxmlformats.org/drawingml/2006/main" xmlns:r="http://schemas.openxmlformats.org/officeDocument/2006/relationships" xmlns:p="http://schemas.openxmlformats.org/presentationml/2006/main">
   <p:cSld>
     <p:spTree>
       <p:nvGrpSpPr>
@@ -5287,7 +5335,14 @@
         <p:cNvGrpSpPr/>
         <p:nvPr/>
       </p:nvGrpSpPr>
-      <p:grpSpPr/>
+      <p:grpSpPr>
+        <a:xfrm>
+          <a:off x="0" y="0"/>
+          <a:ext cx="0" cy="0"/>
+          <a:chOff x="0" y="0"/>
+          <a:chExt cx="0" cy="0"/>
+        </a:xfrm>
+      </p:grpSpPr>
       <p:sp>
         <p:nvSpPr>
           <p:cNvPr id="2" name="Rectangle 1"/>
@@ -5328,6 +5383,7 @@
           <a:lstStyle/>
           <a:p>
             <a:pPr algn="ctr"/>
+            <a:endParaRPr/>
           </a:p>
         </p:txBody>
       </p:sp>
@@ -5521,7 +5577,7 @@
 </file>
 
 <file path=ppt/slides/slide6.xml><?xml version="1.0" encoding="utf-8"?>
-<p:sld xmlns:a="http://schemas.openxmlformats.org/drawingml/2006/main" xmlns:p="http://schemas.openxmlformats.org/presentationml/2006/main" xmlns:r="http://schemas.openxmlformats.org/officeDocument/2006/relationships">
+<p:sld xmlns:a="http://schemas.openxmlformats.org/drawingml/2006/main" xmlns:r="http://schemas.openxmlformats.org/officeDocument/2006/relationships" xmlns:p="http://schemas.openxmlformats.org/presentationml/2006/main">
   <p:cSld>
     <p:spTree>
       <p:nvGrpSpPr>
@@ -5529,7 +5585,14 @@
         <p:cNvGrpSpPr/>
         <p:nvPr/>
       </p:nvGrpSpPr>
-      <p:grpSpPr/>
+      <p:grpSpPr>
+        <a:xfrm>
+          <a:off x="0" y="0"/>
+          <a:ext cx="0" cy="0"/>
+          <a:chOff x="0" y="0"/>
+          <a:chExt cx="0" cy="0"/>
+        </a:xfrm>
+      </p:grpSpPr>
       <p:sp>
         <p:nvSpPr>
           <p:cNvPr id="2" name="Rectangle 1"/>
@@ -5570,6 +5633,7 @@
           <a:lstStyle/>
           <a:p>
             <a:pPr algn="ctr"/>
+            <a:endParaRPr/>
           </a:p>
         </p:txBody>
       </p:sp>
@@ -5795,7 +5859,7 @@
 </file>
 
 <file path=ppt/slides/slide7.xml><?xml version="1.0" encoding="utf-8"?>
-<p:sld xmlns:a="http://schemas.openxmlformats.org/drawingml/2006/main" xmlns:p="http://schemas.openxmlformats.org/presentationml/2006/main" xmlns:r="http://schemas.openxmlformats.org/officeDocument/2006/relationships">
+<p:sld xmlns:a="http://schemas.openxmlformats.org/drawingml/2006/main" xmlns:r="http://schemas.openxmlformats.org/officeDocument/2006/relationships" xmlns:p="http://schemas.openxmlformats.org/presentationml/2006/main">
   <p:cSld>
     <p:spTree>
       <p:nvGrpSpPr>
@@ -5803,7 +5867,14 @@
         <p:cNvGrpSpPr/>
         <p:nvPr/>
       </p:nvGrpSpPr>
-      <p:grpSpPr/>
+      <p:grpSpPr>
+        <a:xfrm>
+          <a:off x="0" y="0"/>
+          <a:ext cx="0" cy="0"/>
+          <a:chOff x="0" y="0"/>
+          <a:chExt cx="0" cy="0"/>
+        </a:xfrm>
+      </p:grpSpPr>
       <p:sp>
         <p:nvSpPr>
           <p:cNvPr id="2" name="Rectangle 1"/>
@@ -5844,6 +5915,7 @@
           <a:lstStyle/>
           <a:p>
             <a:pPr algn="ctr"/>
+            <a:endParaRPr/>
           </a:p>
         </p:txBody>
       </p:sp>
@@ -6037,7 +6109,7 @@
 </file>
 
 <file path=ppt/slides/slide8.xml><?xml version="1.0" encoding="utf-8"?>
-<p:sld xmlns:a="http://schemas.openxmlformats.org/drawingml/2006/main" xmlns:p="http://schemas.openxmlformats.org/presentationml/2006/main" xmlns:r="http://schemas.openxmlformats.org/officeDocument/2006/relationships">
+<p:sld xmlns:a="http://schemas.openxmlformats.org/drawingml/2006/main" xmlns:r="http://schemas.openxmlformats.org/officeDocument/2006/relationships" xmlns:p="http://schemas.openxmlformats.org/presentationml/2006/main">
   <p:cSld>
     <p:spTree>
       <p:nvGrpSpPr>
@@ -6045,7 +6117,14 @@
         <p:cNvGrpSpPr/>
         <p:nvPr/>
       </p:nvGrpSpPr>
-      <p:grpSpPr/>
+      <p:grpSpPr>
+        <a:xfrm>
+          <a:off x="0" y="0"/>
+          <a:ext cx="0" cy="0"/>
+          <a:chOff x="0" y="0"/>
+          <a:chExt cx="0" cy="0"/>
+        </a:xfrm>
+      </p:grpSpPr>
       <p:sp>
         <p:nvSpPr>
           <p:cNvPr id="2" name="Rectangle 1"/>
@@ -6086,6 +6165,7 @@
           <a:lstStyle/>
           <a:p>
             <a:pPr algn="ctr"/>
+            <a:endParaRPr/>
           </a:p>
         </p:txBody>
       </p:sp>
@@ -6211,13 +6291,103 @@
               </a:spcAft>
             </a:pPr>
             <a:r>
-              <a:rPr sz="2000">
-                <a:solidFill>
-                  <a:srgbClr val="1F2937"/>
-                </a:solidFill>
-                <a:latin typeface="Arial"/>
-              </a:rPr>
-              <a:t>•  1.  Guardarlo en Drive como siempre (escritorio)</a:t>
+              <a:rPr sz="2000" dirty="0">
+                <a:solidFill>
+                  <a:srgbClr val="1F2937"/>
+                </a:solidFill>
+                <a:latin typeface="Arial"/>
+              </a:rPr>
+              <a:t>•  1.  </a:t>
+            </a:r>
+            <a:r>
+              <a:rPr sz="2000" dirty="0" err="1">
+                <a:solidFill>
+                  <a:srgbClr val="1F2937"/>
+                </a:solidFill>
+                <a:latin typeface="Arial"/>
+              </a:rPr>
+              <a:t>Guardarlo</a:t>
+            </a:r>
+            <a:r>
+              <a:rPr sz="2000" dirty="0">
+                <a:solidFill>
+                  <a:srgbClr val="1F2937"/>
+                </a:solidFill>
+                <a:latin typeface="Arial"/>
+              </a:rPr>
+              <a:t> </a:t>
+            </a:r>
+            <a:r>
+              <a:rPr sz="2000" dirty="0" err="1">
+                <a:solidFill>
+                  <a:srgbClr val="1F2937"/>
+                </a:solidFill>
+                <a:latin typeface="Arial"/>
+              </a:rPr>
+              <a:t>en</a:t>
+            </a:r>
+            <a:r>
+              <a:rPr sz="2000" dirty="0">
+                <a:solidFill>
+                  <a:srgbClr val="1F2937"/>
+                </a:solidFill>
+                <a:latin typeface="Arial"/>
+              </a:rPr>
+              <a:t> Drive </a:t>
+            </a:r>
+            <a:r>
+              <a:rPr sz="2000" dirty="0" err="1">
+                <a:solidFill>
+                  <a:srgbClr val="1F2937"/>
+                </a:solidFill>
+                <a:latin typeface="Arial"/>
+              </a:rPr>
+              <a:t>como</a:t>
+            </a:r>
+            <a:r>
+              <a:rPr sz="2000" dirty="0">
+                <a:solidFill>
+                  <a:srgbClr val="1F2937"/>
+                </a:solidFill>
+                <a:latin typeface="Arial"/>
+              </a:rPr>
+              <a:t> </a:t>
+            </a:r>
+            <a:r>
+              <a:rPr sz="2000" dirty="0" err="1">
+                <a:solidFill>
+                  <a:srgbClr val="1F2937"/>
+                </a:solidFill>
+                <a:latin typeface="Arial"/>
+              </a:rPr>
+              <a:t>siempre</a:t>
+            </a:r>
+            <a:r>
+              <a:rPr sz="2000" dirty="0">
+                <a:solidFill>
+                  <a:srgbClr val="1F2937"/>
+                </a:solidFill>
+                <a:latin typeface="Arial"/>
+              </a:rPr>
+              <a:t> (</a:t>
+            </a:r>
+            <a:r>
+              <a:rPr sz="2000" dirty="0" err="1">
+                <a:solidFill>
+                  <a:srgbClr val="1F2937"/>
+                </a:solidFill>
+                <a:latin typeface="Arial"/>
+              </a:rPr>
+              <a:t>escritorio</a:t>
+            </a:r>
+            <a:r>
+              <a:rPr sz="2000" dirty="0">
+                <a:solidFill>
+                  <a:srgbClr val="1F2937"/>
+                </a:solidFill>
+                <a:latin typeface="Arial"/>
+              </a:rPr>
+              <a:t>)</a:t>
             </a:r>
           </a:p>
           <a:p>
@@ -6227,13 +6397,139 @@
               </a:spcAft>
             </a:pPr>
             <a:r>
-              <a:rPr sz="2000">
-                <a:solidFill>
-                  <a:srgbClr val="1F2937"/>
-                </a:solidFill>
-                <a:latin typeface="Arial"/>
-              </a:rPr>
-              <a:t>•  2.  Subirlo al estante público (botón Upload en el navegador)</a:t>
+              <a:rPr sz="2000" dirty="0">
+                <a:solidFill>
+                  <a:srgbClr val="1F2937"/>
+                </a:solidFill>
+                <a:latin typeface="Arial"/>
+              </a:rPr>
+              <a:t>•  2.  </a:t>
+            </a:r>
+            <a:r>
+              <a:rPr sz="2000" dirty="0" err="1">
+                <a:solidFill>
+                  <a:srgbClr val="1F2937"/>
+                </a:solidFill>
+                <a:latin typeface="Arial"/>
+              </a:rPr>
+              <a:t>Subirlo</a:t>
+            </a:r>
+            <a:r>
+              <a:rPr sz="2000" dirty="0">
+                <a:solidFill>
+                  <a:srgbClr val="1F2937"/>
+                </a:solidFill>
+                <a:latin typeface="Arial"/>
+              </a:rPr>
+              <a:t> al </a:t>
+            </a:r>
+            <a:r>
+              <a:rPr sz="2000" dirty="0" err="1">
+                <a:solidFill>
+                  <a:srgbClr val="1F2937"/>
+                </a:solidFill>
+                <a:latin typeface="Arial"/>
+              </a:rPr>
+              <a:t>estante</a:t>
+            </a:r>
+            <a:r>
+              <a:rPr sz="2000" dirty="0">
+                <a:solidFill>
+                  <a:srgbClr val="1F2937"/>
+                </a:solidFill>
+                <a:latin typeface="Arial"/>
+              </a:rPr>
+              <a:t> </a:t>
+            </a:r>
+            <a:r>
+              <a:rPr sz="2000" dirty="0" err="1">
+                <a:solidFill>
+                  <a:srgbClr val="1F2937"/>
+                </a:solidFill>
+                <a:latin typeface="Arial"/>
+              </a:rPr>
+              <a:t>público</a:t>
+            </a:r>
+            <a:r>
+              <a:rPr sz="2000" dirty="0">
+                <a:solidFill>
+                  <a:srgbClr val="1F2937"/>
+                </a:solidFill>
+                <a:latin typeface="Arial"/>
+              </a:rPr>
+              <a:t> (</a:t>
+            </a:r>
+            <a:r>
+              <a:rPr sz="2000" dirty="0" err="1">
+                <a:solidFill>
+                  <a:srgbClr val="1F2937"/>
+                </a:solidFill>
+                <a:latin typeface="Arial"/>
+              </a:rPr>
+              <a:t>botón</a:t>
+            </a:r>
+            <a:r>
+              <a:rPr sz="2000" dirty="0">
+                <a:solidFill>
+                  <a:srgbClr val="1F2937"/>
+                </a:solidFill>
+                <a:latin typeface="Arial"/>
+              </a:rPr>
+              <a:t> Upload </a:t>
+            </a:r>
+            <a:r>
+              <a:rPr sz="2000" dirty="0" err="1">
+                <a:solidFill>
+                  <a:srgbClr val="1F2937"/>
+                </a:solidFill>
+                <a:latin typeface="Arial"/>
+              </a:rPr>
+              <a:t>en</a:t>
+            </a:r>
+            <a:r>
+              <a:rPr sz="2000" dirty="0">
+                <a:solidFill>
+                  <a:srgbClr val="1F2937"/>
+                </a:solidFill>
+                <a:latin typeface="Arial"/>
+              </a:rPr>
+              <a:t> </a:t>
+            </a:r>
+            <a:r>
+              <a:rPr sz="2000" dirty="0" err="1">
+                <a:solidFill>
+                  <a:srgbClr val="1F2937"/>
+                </a:solidFill>
+                <a:latin typeface="Arial"/>
+              </a:rPr>
+              <a:t>el</a:t>
+            </a:r>
+            <a:r>
+              <a:rPr sz="2000" dirty="0">
+                <a:solidFill>
+                  <a:srgbClr val="1F2937"/>
+                </a:solidFill>
+                <a:latin typeface="Arial"/>
+              </a:rPr>
+              <a:t> </a:t>
+            </a:r>
+            <a:r>
+              <a:rPr sz="2000" dirty="0" err="1">
+                <a:solidFill>
+                  <a:srgbClr val="1F2937"/>
+                </a:solidFill>
+                <a:latin typeface="Arial"/>
+              </a:rPr>
+              <a:t>navegador</a:t>
+            </a:r>
+            <a:r>
+              <a:rPr sz="2000" dirty="0">
+                <a:solidFill>
+                  <a:srgbClr val="1F2937"/>
+                </a:solidFill>
+                <a:latin typeface="Arial"/>
+              </a:rPr>
+              <a:t>)</a:t>
             </a:r>
           </a:p>
           <a:p>
@@ -6243,13 +6539,121 @@
               </a:spcAft>
             </a:pPr>
             <a:r>
-              <a:rPr sz="2000">
-                <a:solidFill>
-                  <a:srgbClr val="1F2937"/>
-                </a:solidFill>
-                <a:latin typeface="Arial"/>
-              </a:rPr>
-              <a:t>•  3.  Esperar la indexación (vamos a cronometrar cuánto tarda)</a:t>
+              <a:rPr sz="2000" dirty="0">
+                <a:solidFill>
+                  <a:srgbClr val="1F2937"/>
+                </a:solidFill>
+                <a:latin typeface="Arial"/>
+              </a:rPr>
+              <a:t>•  3.  </a:t>
+            </a:r>
+            <a:r>
+              <a:rPr sz="2000" dirty="0" err="1">
+                <a:solidFill>
+                  <a:srgbClr val="1F2937"/>
+                </a:solidFill>
+                <a:latin typeface="Arial"/>
+              </a:rPr>
+              <a:t>Esperar</a:t>
+            </a:r>
+            <a:r>
+              <a:rPr sz="2000" dirty="0">
+                <a:solidFill>
+                  <a:srgbClr val="1F2937"/>
+                </a:solidFill>
+                <a:latin typeface="Arial"/>
+              </a:rPr>
+              <a:t> la </a:t>
+            </a:r>
+            <a:r>
+              <a:rPr sz="2000" dirty="0" err="1">
+                <a:solidFill>
+                  <a:srgbClr val="1F2937"/>
+                </a:solidFill>
+                <a:latin typeface="Arial"/>
+              </a:rPr>
+              <a:t>indexación</a:t>
+            </a:r>
+            <a:r>
+              <a:rPr sz="2000" dirty="0">
+                <a:solidFill>
+                  <a:srgbClr val="1F2937"/>
+                </a:solidFill>
+                <a:latin typeface="Arial"/>
+              </a:rPr>
+              <a:t> (</a:t>
+            </a:r>
+            <a:r>
+              <a:rPr sz="2000" dirty="0" err="1">
+                <a:solidFill>
+                  <a:srgbClr val="1F2937"/>
+                </a:solidFill>
+                <a:latin typeface="Arial"/>
+              </a:rPr>
+              <a:t>vamos</a:t>
+            </a:r>
+            <a:r>
+              <a:rPr sz="2000" dirty="0">
+                <a:solidFill>
+                  <a:srgbClr val="1F2937"/>
+                </a:solidFill>
+                <a:latin typeface="Arial"/>
+              </a:rPr>
+              <a:t> a </a:t>
+            </a:r>
+            <a:r>
+              <a:rPr sz="2000" dirty="0" err="1">
+                <a:solidFill>
+                  <a:srgbClr val="1F2937"/>
+                </a:solidFill>
+                <a:latin typeface="Arial"/>
+              </a:rPr>
+              <a:t>cronometrar</a:t>
+            </a:r>
+            <a:r>
+              <a:rPr sz="2000" dirty="0">
+                <a:solidFill>
+                  <a:srgbClr val="1F2937"/>
+                </a:solidFill>
+                <a:latin typeface="Arial"/>
+              </a:rPr>
+              <a:t> </a:t>
+            </a:r>
+            <a:r>
+              <a:rPr sz="2000" dirty="0" err="1">
+                <a:solidFill>
+                  <a:srgbClr val="1F2937"/>
+                </a:solidFill>
+                <a:latin typeface="Arial"/>
+              </a:rPr>
+              <a:t>cuánto</a:t>
+            </a:r>
+            <a:r>
+              <a:rPr sz="2000" dirty="0">
+                <a:solidFill>
+                  <a:srgbClr val="1F2937"/>
+                </a:solidFill>
+                <a:latin typeface="Arial"/>
+              </a:rPr>
+              <a:t> </a:t>
+            </a:r>
+            <a:r>
+              <a:rPr sz="2000" dirty="0" err="1">
+                <a:solidFill>
+                  <a:srgbClr val="1F2937"/>
+                </a:solidFill>
+                <a:latin typeface="Arial"/>
+              </a:rPr>
+              <a:t>tarda</a:t>
+            </a:r>
+            <a:r>
+              <a:rPr sz="2000" dirty="0">
+                <a:solidFill>
+                  <a:srgbClr val="1F2937"/>
+                </a:solidFill>
+                <a:latin typeface="Arial"/>
+              </a:rPr>
+              <a:t>)</a:t>
             </a:r>
           </a:p>
           <a:p>
@@ -6259,14 +6663,155 @@
               </a:spcAft>
             </a:pPr>
             <a:r>
-              <a:rPr sz="2000">
-                <a:solidFill>
-                  <a:srgbClr val="1F2937"/>
-                </a:solidFill>
-                <a:latin typeface="Arial"/>
-              </a:rPr>
-              <a:t>•  4.  Verificar: hacerle al asistente una pregunta que solo ese documento responde</a:t>
-            </a:r>
+              <a:rPr sz="2000" dirty="0">
+                <a:solidFill>
+                  <a:srgbClr val="1F2937"/>
+                </a:solidFill>
+                <a:latin typeface="Arial"/>
+              </a:rPr>
+              <a:t>•  4.  </a:t>
+            </a:r>
+            <a:r>
+              <a:rPr sz="2000" dirty="0" err="1">
+                <a:solidFill>
+                  <a:srgbClr val="1F2937"/>
+                </a:solidFill>
+                <a:latin typeface="Arial"/>
+              </a:rPr>
+              <a:t>Verificar</a:t>
+            </a:r>
+            <a:r>
+              <a:rPr sz="2000" dirty="0">
+                <a:solidFill>
+                  <a:srgbClr val="1F2937"/>
+                </a:solidFill>
+                <a:latin typeface="Arial"/>
+              </a:rPr>
+              <a:t>: </a:t>
+            </a:r>
+            <a:r>
+              <a:rPr sz="2000" dirty="0" err="1">
+                <a:solidFill>
+                  <a:srgbClr val="1F2937"/>
+                </a:solidFill>
+                <a:latin typeface="Arial"/>
+              </a:rPr>
+              <a:t>hacerle</a:t>
+            </a:r>
+            <a:r>
+              <a:rPr sz="2000" dirty="0">
+                <a:solidFill>
+                  <a:srgbClr val="1F2937"/>
+                </a:solidFill>
+                <a:latin typeface="Arial"/>
+              </a:rPr>
+              <a:t> al </a:t>
+            </a:r>
+            <a:r>
+              <a:rPr sz="2000" dirty="0" err="1">
+                <a:solidFill>
+                  <a:srgbClr val="1F2937"/>
+                </a:solidFill>
+                <a:latin typeface="Arial"/>
+              </a:rPr>
+              <a:t>asistente</a:t>
+            </a:r>
+            <a:r>
+              <a:rPr sz="2000" dirty="0">
+                <a:solidFill>
+                  <a:srgbClr val="1F2937"/>
+                </a:solidFill>
+                <a:latin typeface="Arial"/>
+              </a:rPr>
+              <a:t> </a:t>
+            </a:r>
+            <a:r>
+              <a:rPr sz="2000" dirty="0" err="1">
+                <a:solidFill>
+                  <a:srgbClr val="1F2937"/>
+                </a:solidFill>
+                <a:latin typeface="Arial"/>
+              </a:rPr>
+              <a:t>una</a:t>
+            </a:r>
+            <a:r>
+              <a:rPr sz="2000" dirty="0">
+                <a:solidFill>
+                  <a:srgbClr val="1F2937"/>
+                </a:solidFill>
+                <a:latin typeface="Arial"/>
+              </a:rPr>
+              <a:t> </a:t>
+            </a:r>
+            <a:r>
+              <a:rPr sz="2000" dirty="0" err="1">
+                <a:solidFill>
+                  <a:srgbClr val="1F2937"/>
+                </a:solidFill>
+                <a:latin typeface="Arial"/>
+              </a:rPr>
+              <a:t>pregunta</a:t>
+            </a:r>
+            <a:r>
+              <a:rPr sz="2000" dirty="0">
+                <a:solidFill>
+                  <a:srgbClr val="1F2937"/>
+                </a:solidFill>
+                <a:latin typeface="Arial"/>
+              </a:rPr>
+              <a:t> </a:t>
+            </a:r>
+            <a:r>
+              <a:rPr sz="2000" dirty="0" err="1">
+                <a:solidFill>
+                  <a:srgbClr val="1F2937"/>
+                </a:solidFill>
+                <a:latin typeface="Arial"/>
+              </a:rPr>
+              <a:t>que</a:t>
+            </a:r>
+            <a:r>
+              <a:rPr sz="2000" dirty="0">
+                <a:solidFill>
+                  <a:srgbClr val="1F2937"/>
+                </a:solidFill>
+                <a:latin typeface="Arial"/>
+              </a:rPr>
+              <a:t> solo ese </a:t>
+            </a:r>
+            <a:r>
+              <a:rPr sz="2000" dirty="0" err="1">
+                <a:solidFill>
+                  <a:srgbClr val="1F2937"/>
+                </a:solidFill>
+                <a:latin typeface="Arial"/>
+              </a:rPr>
+              <a:t>documento</a:t>
+            </a:r>
+            <a:r>
+              <a:rPr sz="2000" dirty="0">
+                <a:solidFill>
+                  <a:srgbClr val="1F2937"/>
+                </a:solidFill>
+                <a:latin typeface="Arial"/>
+              </a:rPr>
+              <a:t> </a:t>
+            </a:r>
+            <a:r>
+              <a:rPr sz="2000" dirty="0" err="1">
+                <a:solidFill>
+                  <a:srgbClr val="1F2937"/>
+                </a:solidFill>
+                <a:latin typeface="Arial"/>
+              </a:rPr>
+              <a:t>responde</a:t>
+            </a:r>
+            <a:endParaRPr sz="2000" dirty="0">
+              <a:solidFill>
+                <a:srgbClr val="1F2937"/>
+              </a:solidFill>
+              <a:latin typeface="Arial"/>
+            </a:endParaRPr>
           </a:p>
           <a:p>
             <a:pPr>
@@ -6275,14 +6820,137 @@
               </a:spcAft>
             </a:pPr>
             <a:r>
-              <a:rPr sz="2000">
-                <a:solidFill>
-                  <a:srgbClr val="1F2937"/>
-                </a:solidFill>
-                <a:latin typeface="Arial"/>
-              </a:rPr>
-              <a:t>•  Este circuito es el corazón de su autonomía — lo van a hacer sin ayuda</a:t>
-            </a:r>
+              <a:rPr sz="2000" dirty="0">
+                <a:solidFill>
+                  <a:srgbClr val="1F2937"/>
+                </a:solidFill>
+                <a:latin typeface="Arial"/>
+              </a:rPr>
+              <a:t>•  Este </a:t>
+            </a:r>
+            <a:r>
+              <a:rPr sz="2000" dirty="0" err="1">
+                <a:solidFill>
+                  <a:srgbClr val="1F2937"/>
+                </a:solidFill>
+                <a:latin typeface="Arial"/>
+              </a:rPr>
+              <a:t>circuito</a:t>
+            </a:r>
+            <a:r>
+              <a:rPr sz="2000" dirty="0">
+                <a:solidFill>
+                  <a:srgbClr val="1F2937"/>
+                </a:solidFill>
+                <a:latin typeface="Arial"/>
+              </a:rPr>
+              <a:t> es </a:t>
+            </a:r>
+            <a:r>
+              <a:rPr sz="2000" dirty="0" err="1">
+                <a:solidFill>
+                  <a:srgbClr val="1F2937"/>
+                </a:solidFill>
+                <a:latin typeface="Arial"/>
+              </a:rPr>
+              <a:t>el</a:t>
+            </a:r>
+            <a:r>
+              <a:rPr sz="2000" dirty="0">
+                <a:solidFill>
+                  <a:srgbClr val="1F2937"/>
+                </a:solidFill>
+                <a:latin typeface="Arial"/>
+              </a:rPr>
+              <a:t> </a:t>
+            </a:r>
+            <a:r>
+              <a:rPr sz="2000" dirty="0" err="1">
+                <a:solidFill>
+                  <a:srgbClr val="1F2937"/>
+                </a:solidFill>
+                <a:latin typeface="Arial"/>
+              </a:rPr>
+              <a:t>corazón</a:t>
+            </a:r>
+            <a:r>
+              <a:rPr sz="2000" dirty="0">
+                <a:solidFill>
+                  <a:srgbClr val="1F2937"/>
+                </a:solidFill>
+                <a:latin typeface="Arial"/>
+              </a:rPr>
+              <a:t> de </a:t>
+            </a:r>
+            <a:r>
+              <a:rPr sz="2000" dirty="0" err="1">
+                <a:solidFill>
+                  <a:srgbClr val="1F2937"/>
+                </a:solidFill>
+                <a:latin typeface="Arial"/>
+              </a:rPr>
+              <a:t>su</a:t>
+            </a:r>
+            <a:r>
+              <a:rPr sz="2000" dirty="0">
+                <a:solidFill>
+                  <a:srgbClr val="1F2937"/>
+                </a:solidFill>
+                <a:latin typeface="Arial"/>
+              </a:rPr>
+              <a:t> </a:t>
+            </a:r>
+            <a:r>
+              <a:rPr sz="2000" dirty="0" err="1">
+                <a:solidFill>
+                  <a:srgbClr val="1F2937"/>
+                </a:solidFill>
+                <a:latin typeface="Arial"/>
+              </a:rPr>
+              <a:t>autonomía</a:t>
+            </a:r>
+            <a:r>
+              <a:rPr sz="2000" dirty="0">
+                <a:solidFill>
+                  <a:srgbClr val="1F2937"/>
+                </a:solidFill>
+                <a:latin typeface="Arial"/>
+              </a:rPr>
+              <a:t> — lo van a </a:t>
+            </a:r>
+            <a:r>
+              <a:rPr sz="2000" dirty="0" err="1">
+                <a:solidFill>
+                  <a:srgbClr val="1F2937"/>
+                </a:solidFill>
+                <a:latin typeface="Arial"/>
+              </a:rPr>
+              <a:t>hacer</a:t>
+            </a:r>
+            <a:r>
+              <a:rPr sz="2000" dirty="0">
+                <a:solidFill>
+                  <a:srgbClr val="1F2937"/>
+                </a:solidFill>
+                <a:latin typeface="Arial"/>
+              </a:rPr>
+              <a:t> sin </a:t>
+            </a:r>
+            <a:r>
+              <a:rPr sz="2000" dirty="0" err="1">
+                <a:solidFill>
+                  <a:srgbClr val="1F2937"/>
+                </a:solidFill>
+                <a:latin typeface="Arial"/>
+              </a:rPr>
+              <a:t>ayuda</a:t>
+            </a:r>
+            <a:endParaRPr sz="2000" dirty="0">
+              <a:solidFill>
+                <a:srgbClr val="1F2937"/>
+              </a:solidFill>
+              <a:latin typeface="Arial"/>
+            </a:endParaRPr>
           </a:p>
         </p:txBody>
       </p:sp>
@@ -6295,7 +6963,7 @@
 </file>
 
 <file path=ppt/slides/slide9.xml><?xml version="1.0" encoding="utf-8"?>
-<p:sld xmlns:a="http://schemas.openxmlformats.org/drawingml/2006/main" xmlns:p="http://schemas.openxmlformats.org/presentationml/2006/main" xmlns:r="http://schemas.openxmlformats.org/officeDocument/2006/relationships">
+<p:sld xmlns:a="http://schemas.openxmlformats.org/drawingml/2006/main" xmlns:r="http://schemas.openxmlformats.org/officeDocument/2006/relationships" xmlns:p="http://schemas.openxmlformats.org/presentationml/2006/main">
   <p:cSld>
     <p:spTree>
       <p:nvGrpSpPr>
@@ -6303,7 +6971,14 @@
         <p:cNvGrpSpPr/>
         <p:nvPr/>
       </p:nvGrpSpPr>
-      <p:grpSpPr/>
+      <p:grpSpPr>
+        <a:xfrm>
+          <a:off x="0" y="0"/>
+          <a:ext cx="0" cy="0"/>
+          <a:chOff x="0" y="0"/>
+          <a:chExt cx="0" cy="0"/>
+        </a:xfrm>
+      </p:grpSpPr>
       <p:sp>
         <p:nvSpPr>
           <p:cNvPr id="2" name="Rectangle 1"/>
@@ -6344,6 +7019,7 @@
           <a:lstStyle/>
           <a:p>
             <a:pPr algn="ctr"/>
+            <a:endParaRPr/>
           </a:p>
         </p:txBody>
       </p:sp>
@@ -6450,7 +7126,7 @@
         <p:spPr>
           <a:xfrm>
             <a:off x="868680" y="1737360"/>
-            <a:ext cx="10515600" cy="4480560"/>
+            <a:ext cx="10515600" cy="2477601"/>
           </a:xfrm>
           <a:prstGeom prst="rect">
             <a:avLst/>
@@ -6469,14 +7145,155 @@
               </a:spcAft>
             </a:pPr>
             <a:r>
-              <a:rPr sz="2000">
-                <a:solidFill>
-                  <a:srgbClr val="1F2937"/>
-                </a:solidFill>
-                <a:latin typeface="Arial"/>
-              </a:rPr>
-              <a:t>•  Equipo: terminar de cargar el material verde; separar escaneos y láminas problemáticos</a:t>
-            </a:r>
+              <a:rPr sz="2000" dirty="0">
+                <a:solidFill>
+                  <a:srgbClr val="1F2937"/>
+                </a:solidFill>
+                <a:latin typeface="Arial"/>
+              </a:rPr>
+              <a:t>•  Equipo: </a:t>
+            </a:r>
+            <a:r>
+              <a:rPr sz="2000" dirty="0" err="1">
+                <a:solidFill>
+                  <a:srgbClr val="1F2937"/>
+                </a:solidFill>
+                <a:latin typeface="Arial"/>
+              </a:rPr>
+              <a:t>terminar</a:t>
+            </a:r>
+            <a:r>
+              <a:rPr sz="2000" dirty="0">
+                <a:solidFill>
+                  <a:srgbClr val="1F2937"/>
+                </a:solidFill>
+                <a:latin typeface="Arial"/>
+              </a:rPr>
+              <a:t> de </a:t>
+            </a:r>
+            <a:r>
+              <a:rPr sz="2000" dirty="0" err="1">
+                <a:solidFill>
+                  <a:srgbClr val="1F2937"/>
+                </a:solidFill>
+                <a:latin typeface="Arial"/>
+              </a:rPr>
+              <a:t>cargar</a:t>
+            </a:r>
+            <a:r>
+              <a:rPr sz="2000" dirty="0">
+                <a:solidFill>
+                  <a:srgbClr val="1F2937"/>
+                </a:solidFill>
+                <a:latin typeface="Arial"/>
+              </a:rPr>
+              <a:t> </a:t>
+            </a:r>
+            <a:r>
+              <a:rPr sz="2000" dirty="0" err="1">
+                <a:solidFill>
+                  <a:srgbClr val="1F2937"/>
+                </a:solidFill>
+                <a:latin typeface="Arial"/>
+              </a:rPr>
+              <a:t>el</a:t>
+            </a:r>
+            <a:r>
+              <a:rPr sz="2000" dirty="0">
+                <a:solidFill>
+                  <a:srgbClr val="1F2937"/>
+                </a:solidFill>
+                <a:latin typeface="Arial"/>
+              </a:rPr>
+              <a:t> material </a:t>
+            </a:r>
+            <a:r>
+              <a:rPr sz="2000" dirty="0" err="1">
+                <a:solidFill>
+                  <a:srgbClr val="1F2937"/>
+                </a:solidFill>
+                <a:latin typeface="Arial"/>
+              </a:rPr>
+              <a:t>verde</a:t>
+            </a:r>
+            <a:r>
+              <a:rPr sz="2000" dirty="0">
+                <a:solidFill>
+                  <a:srgbClr val="1F2937"/>
+                </a:solidFill>
+                <a:latin typeface="Arial"/>
+              </a:rPr>
+              <a:t>; </a:t>
+            </a:r>
+            <a:r>
+              <a:rPr sz="2000" dirty="0" err="1">
+                <a:solidFill>
+                  <a:srgbClr val="1F2937"/>
+                </a:solidFill>
+                <a:latin typeface="Arial"/>
+              </a:rPr>
+              <a:t>separar</a:t>
+            </a:r>
+            <a:r>
+              <a:rPr sz="2000" dirty="0">
+                <a:solidFill>
+                  <a:srgbClr val="1F2937"/>
+                </a:solidFill>
+                <a:latin typeface="Arial"/>
+              </a:rPr>
+              <a:t> </a:t>
+            </a:r>
+            <a:r>
+              <a:rPr sz="2000" dirty="0" err="1">
+                <a:solidFill>
+                  <a:srgbClr val="1F2937"/>
+                </a:solidFill>
+                <a:latin typeface="Arial"/>
+              </a:rPr>
+              <a:t>escaneos</a:t>
+            </a:r>
+            <a:r>
+              <a:rPr sz="2000" dirty="0">
+                <a:solidFill>
+                  <a:srgbClr val="1F2937"/>
+                </a:solidFill>
+                <a:latin typeface="Arial"/>
+              </a:rPr>
+              <a:t> y </a:t>
+            </a:r>
+            <a:r>
+              <a:rPr sz="2000" dirty="0" err="1">
+                <a:solidFill>
+                  <a:srgbClr val="1F2937"/>
+                </a:solidFill>
+                <a:latin typeface="Arial"/>
+              </a:rPr>
+              <a:t>láminas</a:t>
+            </a:r>
+            <a:r>
+              <a:rPr sz="2000" dirty="0">
+                <a:solidFill>
+                  <a:srgbClr val="1F2937"/>
+                </a:solidFill>
+                <a:latin typeface="Arial"/>
+              </a:rPr>
+              <a:t> </a:t>
+            </a:r>
+            <a:r>
+              <a:rPr sz="2000" dirty="0" err="1">
+                <a:solidFill>
+                  <a:srgbClr val="1F2937"/>
+                </a:solidFill>
+                <a:latin typeface="Arial"/>
+              </a:rPr>
+              <a:t>problemáticos</a:t>
+            </a:r>
+            <a:endParaRPr sz="2000" dirty="0">
+              <a:solidFill>
+                <a:srgbClr val="1F2937"/>
+              </a:solidFill>
+              <a:latin typeface="Arial"/>
+            </a:endParaRPr>
           </a:p>
           <a:p>
             <a:pPr>
@@ -6485,14 +7302,173 @@
               </a:spcAft>
             </a:pPr>
             <a:r>
-              <a:rPr sz="2000">
-                <a:solidFill>
-                  <a:srgbClr val="1F2937"/>
-                </a:solidFill>
-                <a:latin typeface="Arial"/>
-              </a:rPr>
-              <a:t>•  Equipo: completar las fichas (año, autor, tema, resumen) en la planilla del inventario</a:t>
-            </a:r>
+              <a:rPr sz="2000" dirty="0">
+                <a:solidFill>
+                  <a:srgbClr val="1F2937"/>
+                </a:solidFill>
+                <a:latin typeface="Arial"/>
+              </a:rPr>
+              <a:t>•  Equipo: </a:t>
+            </a:r>
+            <a:r>
+              <a:rPr sz="2000" dirty="0" err="1">
+                <a:solidFill>
+                  <a:srgbClr val="1F2937"/>
+                </a:solidFill>
+                <a:latin typeface="Arial"/>
+              </a:rPr>
+              <a:t>completar</a:t>
+            </a:r>
+            <a:r>
+              <a:rPr sz="2000" dirty="0">
+                <a:solidFill>
+                  <a:srgbClr val="1F2937"/>
+                </a:solidFill>
+                <a:latin typeface="Arial"/>
+              </a:rPr>
+              <a:t> las </a:t>
+            </a:r>
+            <a:r>
+              <a:rPr sz="2000" dirty="0" err="1">
+                <a:solidFill>
+                  <a:srgbClr val="1F2937"/>
+                </a:solidFill>
+                <a:latin typeface="Arial"/>
+              </a:rPr>
+              <a:t>fichas</a:t>
+            </a:r>
+            <a:r>
+              <a:rPr sz="2000" dirty="0">
+                <a:solidFill>
+                  <a:srgbClr val="1F2937"/>
+                </a:solidFill>
+                <a:latin typeface="Arial"/>
+              </a:rPr>
+              <a:t> (</a:t>
+            </a:r>
+            <a:r>
+              <a:rPr sz="2000" dirty="0" err="1">
+                <a:solidFill>
+                  <a:srgbClr val="1F2937"/>
+                </a:solidFill>
+                <a:latin typeface="Arial"/>
+              </a:rPr>
+              <a:t>año</a:t>
+            </a:r>
+            <a:r>
+              <a:rPr sz="2000" dirty="0">
+                <a:solidFill>
+                  <a:srgbClr val="1F2937"/>
+                </a:solidFill>
+                <a:latin typeface="Arial"/>
+              </a:rPr>
+              <a:t>, </a:t>
+            </a:r>
+            <a:r>
+              <a:rPr sz="2000" dirty="0" err="1">
+                <a:solidFill>
+                  <a:srgbClr val="1F2937"/>
+                </a:solidFill>
+                <a:latin typeface="Arial"/>
+              </a:rPr>
+              <a:t>autor</a:t>
+            </a:r>
+            <a:r>
+              <a:rPr sz="2000" dirty="0">
+                <a:solidFill>
+                  <a:srgbClr val="1F2937"/>
+                </a:solidFill>
+                <a:latin typeface="Arial"/>
+              </a:rPr>
+              <a:t>, </a:t>
+            </a:r>
+            <a:r>
+              <a:rPr sz="2000" dirty="0" err="1">
+                <a:solidFill>
+                  <a:srgbClr val="1F2937"/>
+                </a:solidFill>
+                <a:latin typeface="Arial"/>
+              </a:rPr>
+              <a:t>tema</a:t>
+            </a:r>
+            <a:r>
+              <a:rPr sz="2000" dirty="0">
+                <a:solidFill>
+                  <a:srgbClr val="1F2937"/>
+                </a:solidFill>
+                <a:latin typeface="Arial"/>
+              </a:rPr>
+              <a:t>, </a:t>
+            </a:r>
+            <a:r>
+              <a:rPr sz="2000" dirty="0" err="1">
+                <a:solidFill>
+                  <a:srgbClr val="1F2937"/>
+                </a:solidFill>
+                <a:latin typeface="Arial"/>
+              </a:rPr>
+              <a:t>resumen</a:t>
+            </a:r>
+            <a:r>
+              <a:rPr sz="2000" dirty="0">
+                <a:solidFill>
+                  <a:srgbClr val="1F2937"/>
+                </a:solidFill>
+                <a:latin typeface="Arial"/>
+              </a:rPr>
+              <a:t>) </a:t>
+            </a:r>
+            <a:r>
+              <a:rPr sz="2000" dirty="0" err="1">
+                <a:solidFill>
+                  <a:srgbClr val="1F2937"/>
+                </a:solidFill>
+                <a:latin typeface="Arial"/>
+              </a:rPr>
+              <a:t>en</a:t>
+            </a:r>
+            <a:r>
+              <a:rPr sz="2000" dirty="0">
+                <a:solidFill>
+                  <a:srgbClr val="1F2937"/>
+                </a:solidFill>
+                <a:latin typeface="Arial"/>
+              </a:rPr>
+              <a:t> la </a:t>
+            </a:r>
+            <a:r>
+              <a:rPr sz="2000" dirty="0" err="1">
+                <a:solidFill>
+                  <a:srgbClr val="1F2937"/>
+                </a:solidFill>
+                <a:latin typeface="Arial"/>
+              </a:rPr>
+              <a:t>planilla</a:t>
+            </a:r>
+            <a:r>
+              <a:rPr sz="2000" dirty="0">
+                <a:solidFill>
+                  <a:srgbClr val="1F2937"/>
+                </a:solidFill>
+                <a:latin typeface="Arial"/>
+              </a:rPr>
+              <a:t> del </a:t>
+            </a:r>
+            <a:r>
+              <a:rPr sz="2000" dirty="0" err="1">
+                <a:solidFill>
+                  <a:srgbClr val="1F2937"/>
+                </a:solidFill>
+                <a:latin typeface="Arial"/>
+              </a:rPr>
+              <a:t>inventario</a:t>
+            </a:r>
+            <a:endParaRPr sz="2000" dirty="0">
+              <a:solidFill>
+                <a:srgbClr val="1F2937"/>
+              </a:solidFill>
+              <a:latin typeface="Arial"/>
+            </a:endParaRPr>
           </a:p>
           <a:p>
             <a:pPr>
@@ -6501,14 +7477,182 @@
               </a:spcAft>
             </a:pPr>
             <a:r>
+              <a:rPr sz="2000" dirty="0">
+                <a:solidFill>
+                  <a:srgbClr val="1F2937"/>
+                </a:solidFill>
+                <a:latin typeface="Arial"/>
+              </a:rPr>
+              <a:t>•  Alejandro</a:t>
+            </a:r>
+            <a:r>
+              <a:rPr lang="en-US" sz="2000" dirty="0">
+                <a:solidFill>
+                  <a:srgbClr val="1F2937"/>
+                </a:solidFill>
+                <a:latin typeface="Arial"/>
+              </a:rPr>
+              <a:t> / Equipo</a:t>
+            </a:r>
+            <a:r>
+              <a:rPr sz="2000" dirty="0">
+                <a:solidFill>
+                  <a:srgbClr val="1F2937"/>
+                </a:solidFill>
+                <a:latin typeface="Arial"/>
+              </a:rPr>
+              <a:t>: </a:t>
+            </a:r>
+            <a:r>
+              <a:rPr sz="2000" dirty="0" err="1">
+                <a:solidFill>
+                  <a:srgbClr val="1F2937"/>
+                </a:solidFill>
+                <a:latin typeface="Arial"/>
+              </a:rPr>
+              <a:t>procesar</a:t>
+            </a:r>
+            <a:r>
+              <a:rPr sz="2000" dirty="0">
+                <a:solidFill>
+                  <a:srgbClr val="1F2937"/>
+                </a:solidFill>
+                <a:latin typeface="Arial"/>
+              </a:rPr>
+              <a:t> </a:t>
+            </a:r>
+            <a:r>
+              <a:rPr sz="2000" dirty="0" err="1">
+                <a:solidFill>
+                  <a:srgbClr val="1F2937"/>
+                </a:solidFill>
+                <a:latin typeface="Arial"/>
+              </a:rPr>
+              <a:t>el</a:t>
+            </a:r>
+            <a:r>
+              <a:rPr sz="2000" dirty="0">
+                <a:solidFill>
+                  <a:srgbClr val="1F2937"/>
+                </a:solidFill>
+                <a:latin typeface="Arial"/>
+              </a:rPr>
+              <a:t> material </a:t>
+            </a:r>
+            <a:r>
+              <a:rPr sz="2000" dirty="0" err="1">
+                <a:solidFill>
+                  <a:srgbClr val="1F2937"/>
+                </a:solidFill>
+                <a:latin typeface="Arial"/>
+              </a:rPr>
+              <a:t>difícil</a:t>
+            </a:r>
+            <a:r>
+              <a:rPr sz="2000" dirty="0">
+                <a:solidFill>
+                  <a:srgbClr val="1F2937"/>
+                </a:solidFill>
+                <a:latin typeface="Arial"/>
+              </a:rPr>
+              <a:t> (</a:t>
+            </a:r>
+            <a:r>
+              <a:rPr lang="en-US" sz="2000" dirty="0">
+                <a:solidFill>
+                  <a:srgbClr val="1F2937"/>
+                </a:solidFill>
+                <a:latin typeface="Arial"/>
+              </a:rPr>
+              <a:t>OCR</a:t>
+            </a:r>
+            <a:r>
+              <a:rPr sz="2000" dirty="0">
+                <a:solidFill>
+                  <a:srgbClr val="1F2937"/>
+                </a:solidFill>
+                <a:latin typeface="Arial"/>
+              </a:rPr>
+              <a:t>, </a:t>
+            </a:r>
+            <a:r>
+              <a:rPr lang="en-US" sz="2000">
+                <a:solidFill>
+                  <a:srgbClr val="1F2937"/>
+                </a:solidFill>
+                <a:latin typeface="Arial"/>
+              </a:rPr>
+              <a:t>videos, </a:t>
+            </a:r>
+            <a:r>
               <a:rPr sz="2000">
                 <a:solidFill>
                   <a:srgbClr val="1F2937"/>
                 </a:solidFill>
                 <a:latin typeface="Arial"/>
               </a:rPr>
-              <a:t>•  Alejandro: procesar el material difícil (OCR, descripciones) y cargar las fichas a la biblioteca</a:t>
-            </a:r>
+              <a:t>descripciones</a:t>
+            </a:r>
+            <a:r>
+              <a:rPr sz="2000" dirty="0">
+                <a:solidFill>
+                  <a:srgbClr val="1F2937"/>
+                </a:solidFill>
+                <a:latin typeface="Arial"/>
+              </a:rPr>
+              <a:t>) y </a:t>
+            </a:r>
+            <a:r>
+              <a:rPr sz="2000" dirty="0" err="1">
+                <a:solidFill>
+                  <a:srgbClr val="1F2937"/>
+                </a:solidFill>
+                <a:latin typeface="Arial"/>
+              </a:rPr>
+              <a:t>cargar</a:t>
+            </a:r>
+            <a:r>
+              <a:rPr sz="2000" dirty="0">
+                <a:solidFill>
+                  <a:srgbClr val="1F2937"/>
+                </a:solidFill>
+                <a:latin typeface="Arial"/>
+              </a:rPr>
+              <a:t> las </a:t>
+            </a:r>
+            <a:r>
+              <a:rPr sz="2000" dirty="0" err="1">
+                <a:solidFill>
+                  <a:srgbClr val="1F2937"/>
+                </a:solidFill>
+                <a:latin typeface="Arial"/>
+              </a:rPr>
+              <a:t>fichas</a:t>
+            </a:r>
+            <a:r>
+              <a:rPr sz="2000" dirty="0">
+                <a:solidFill>
+                  <a:srgbClr val="1F2937"/>
+                </a:solidFill>
+                <a:latin typeface="Arial"/>
+              </a:rPr>
+              <a:t> a la </a:t>
+            </a:r>
+            <a:r>
+              <a:rPr sz="2000" dirty="0" err="1">
+                <a:solidFill>
+                  <a:srgbClr val="1F2937"/>
+                </a:solidFill>
+                <a:latin typeface="Arial"/>
+              </a:rPr>
+              <a:t>biblioteca</a:t>
+            </a:r>
+            <a:endParaRPr sz="2000" dirty="0">
+              <a:solidFill>
+                <a:srgbClr val="1F2937"/>
+              </a:solidFill>
+              <a:latin typeface="Arial"/>
+            </a:endParaRPr>
           </a:p>
           <a:p>
             <a:pPr>
@@ -6517,14 +7661,155 @@
               </a:spcAft>
             </a:pPr>
             <a:r>
-              <a:rPr sz="2000">
-                <a:solidFill>
-                  <a:srgbClr val="1F2937"/>
-                </a:solidFill>
-                <a:latin typeface="Arial"/>
-              </a:rPr>
-              <a:t>•  Próxima sesión: el asistente responde con TODO su material — y aprendemos a evaluarlo</a:t>
-            </a:r>
+              <a:rPr sz="2000" dirty="0">
+                <a:solidFill>
+                  <a:srgbClr val="1F2937"/>
+                </a:solidFill>
+                <a:latin typeface="Arial"/>
+              </a:rPr>
+              <a:t>•  </a:t>
+            </a:r>
+            <a:r>
+              <a:rPr sz="2000" dirty="0" err="1">
+                <a:solidFill>
+                  <a:srgbClr val="1F2937"/>
+                </a:solidFill>
+                <a:latin typeface="Arial"/>
+              </a:rPr>
+              <a:t>Próxima</a:t>
+            </a:r>
+            <a:r>
+              <a:rPr sz="2000" dirty="0">
+                <a:solidFill>
+                  <a:srgbClr val="1F2937"/>
+                </a:solidFill>
+                <a:latin typeface="Arial"/>
+              </a:rPr>
+              <a:t> </a:t>
+            </a:r>
+            <a:r>
+              <a:rPr sz="2000" dirty="0" err="1">
+                <a:solidFill>
+                  <a:srgbClr val="1F2937"/>
+                </a:solidFill>
+                <a:latin typeface="Arial"/>
+              </a:rPr>
+              <a:t>sesión</a:t>
+            </a:r>
+            <a:r>
+              <a:rPr sz="2000" dirty="0">
+                <a:solidFill>
+                  <a:srgbClr val="1F2937"/>
+                </a:solidFill>
+                <a:latin typeface="Arial"/>
+              </a:rPr>
+              <a:t>: </a:t>
+            </a:r>
+            <a:r>
+              <a:rPr sz="2000" dirty="0" err="1">
+                <a:solidFill>
+                  <a:srgbClr val="1F2937"/>
+                </a:solidFill>
+                <a:latin typeface="Arial"/>
+              </a:rPr>
+              <a:t>el</a:t>
+            </a:r>
+            <a:r>
+              <a:rPr sz="2000" dirty="0">
+                <a:solidFill>
+                  <a:srgbClr val="1F2937"/>
+                </a:solidFill>
+                <a:latin typeface="Arial"/>
+              </a:rPr>
+              <a:t> </a:t>
+            </a:r>
+            <a:r>
+              <a:rPr sz="2000" dirty="0" err="1">
+                <a:solidFill>
+                  <a:srgbClr val="1F2937"/>
+                </a:solidFill>
+                <a:latin typeface="Arial"/>
+              </a:rPr>
+              <a:t>asistente</a:t>
+            </a:r>
+            <a:r>
+              <a:rPr sz="2000" dirty="0">
+                <a:solidFill>
+                  <a:srgbClr val="1F2937"/>
+                </a:solidFill>
+                <a:latin typeface="Arial"/>
+              </a:rPr>
+              <a:t> </a:t>
+            </a:r>
+            <a:r>
+              <a:rPr sz="2000" dirty="0" err="1">
+                <a:solidFill>
+                  <a:srgbClr val="1F2937"/>
+                </a:solidFill>
+                <a:latin typeface="Arial"/>
+              </a:rPr>
+              <a:t>responde</a:t>
+            </a:r>
+            <a:r>
+              <a:rPr sz="2000" dirty="0">
+                <a:solidFill>
+                  <a:srgbClr val="1F2937"/>
+                </a:solidFill>
+                <a:latin typeface="Arial"/>
+              </a:rPr>
+              <a:t> con TODO </a:t>
+            </a:r>
+            <a:r>
+              <a:rPr sz="2000" dirty="0" err="1">
+                <a:solidFill>
+                  <a:srgbClr val="1F2937"/>
+                </a:solidFill>
+                <a:latin typeface="Arial"/>
+              </a:rPr>
+              <a:t>su</a:t>
+            </a:r>
+            <a:r>
+              <a:rPr sz="2000" dirty="0">
+                <a:solidFill>
+                  <a:srgbClr val="1F2937"/>
+                </a:solidFill>
+                <a:latin typeface="Arial"/>
+              </a:rPr>
+              <a:t> material — y </a:t>
+            </a:r>
+            <a:r>
+              <a:rPr sz="2000" dirty="0" err="1">
+                <a:solidFill>
+                  <a:srgbClr val="1F2937"/>
+                </a:solidFill>
+                <a:latin typeface="Arial"/>
+              </a:rPr>
+              <a:t>aprendemos</a:t>
+            </a:r>
+            <a:r>
+              <a:rPr sz="2000" dirty="0">
+                <a:solidFill>
+                  <a:srgbClr val="1F2937"/>
+                </a:solidFill>
+                <a:latin typeface="Arial"/>
+              </a:rPr>
+              <a:t> a </a:t>
+            </a:r>
+            <a:r>
+              <a:rPr sz="2000" dirty="0" err="1">
+                <a:solidFill>
+                  <a:srgbClr val="1F2937"/>
+                </a:solidFill>
+                <a:latin typeface="Arial"/>
+              </a:rPr>
+              <a:t>evaluarlo</a:t>
+            </a:r>
+            <a:endParaRPr sz="2000" dirty="0">
+              <a:solidFill>
+                <a:srgbClr val="1F2937"/>
+              </a:solidFill>
+              <a:latin typeface="Arial"/>
+            </a:endParaRPr>
           </a:p>
         </p:txBody>
       </p:sp>
@@ -6857,7 +8142,7 @@
 </file>
 
 <file path=ppt/theme/theme2.xml><?xml version="1.0" encoding="utf-8"?>
-<a:theme xmlns:a="http://schemas.openxmlformats.org/drawingml/2006/main" name="Office Theme">
+<a:theme xmlns:a="http://schemas.openxmlformats.org/drawingml/2006/main" name="Thème Office">
   <a:themeElements>
     <a:clrScheme name="Office">
       <a:dk1>
@@ -6867,44 +8152,44 @@
         <a:sysClr val="window" lastClr="FFFFFF"/>
       </a:lt1>
       <a:dk2>
-        <a:srgbClr val="1F497D"/>
+        <a:srgbClr val="0E2841"/>
       </a:dk2>
       <a:lt2>
-        <a:srgbClr val="EEECE1"/>
+        <a:srgbClr val="E8E8E8"/>
       </a:lt2>
       <a:accent1>
-        <a:srgbClr val="4F81BD"/>
+        <a:srgbClr val="156082"/>
       </a:accent1>
       <a:accent2>
-        <a:srgbClr val="C0504D"/>
+        <a:srgbClr val="E97132"/>
       </a:accent2>
       <a:accent3>
-        <a:srgbClr val="9BBB59"/>
+        <a:srgbClr val="196B24"/>
       </a:accent3>
       <a:accent4>
-        <a:srgbClr val="8064A2"/>
+        <a:srgbClr val="0F9ED5"/>
       </a:accent4>
       <a:accent5>
-        <a:srgbClr val="4BACC6"/>
+        <a:srgbClr val="A02B93"/>
       </a:accent5>
       <a:accent6>
-        <a:srgbClr val="F79646"/>
+        <a:srgbClr val="4EA72E"/>
       </a:accent6>
       <a:hlink>
-        <a:srgbClr val="0000FF"/>
+        <a:srgbClr val="467886"/>
       </a:hlink>
       <a:folHlink>
-        <a:srgbClr val="800080"/>
+        <a:srgbClr val="96607D"/>
       </a:folHlink>
     </a:clrScheme>
     <a:fontScheme name="Office">
       <a:majorFont>
-        <a:latin typeface="Calibri"/>
+        <a:latin typeface="Aptos Display" panose="02110004020202020204"/>
         <a:ea typeface=""/>
         <a:cs typeface=""/>
-        <a:font script="Jpan" typeface="ＭＳ Ｐゴシック"/>
+        <a:font script="Jpan" typeface="游ゴシック Light"/>
         <a:font script="Hang" typeface="맑은 고딕"/>
-        <a:font script="Hans" typeface="宋体"/>
+        <a:font script="Hans" typeface="等线 Light"/>
         <a:font script="Hant" typeface="新細明體"/>
         <a:font script="Arab" typeface="Times New Roman"/>
         <a:font script="Hebr" typeface="Times New Roman"/>
@@ -6932,14 +8217,31 @@
         <a:font script="Viet" typeface="Times New Roman"/>
         <a:font script="Uigh" typeface="Microsoft Uighur"/>
         <a:font script="Geor" typeface="Sylfaen"/>
+        <a:font script="Armn" typeface="Arial"/>
+        <a:font script="Bugi" typeface="Leelawadee UI"/>
+        <a:font script="Bopo" typeface="Microsoft JhengHei"/>
+        <a:font script="Java" typeface="Javanese Text"/>
+        <a:font script="Lisu" typeface="Segoe UI"/>
+        <a:font script="Mymr" typeface="Myanmar Text"/>
+        <a:font script="Nkoo" typeface="Ebrima"/>
+        <a:font script="Olck" typeface="Nirmala UI"/>
+        <a:font script="Osma" typeface="Ebrima"/>
+        <a:font script="Phag" typeface="Phagspa"/>
+        <a:font script="Syrn" typeface="Estrangelo Edessa"/>
+        <a:font script="Syrj" typeface="Estrangelo Edessa"/>
+        <a:font script="Syre" typeface="Estrangelo Edessa"/>
+        <a:font script="Sora" typeface="Nirmala UI"/>
+        <a:font script="Tale" typeface="Microsoft Tai Le"/>
+        <a:font script="Talu" typeface="Microsoft New Tai Lue"/>
+        <a:font script="Tfng" typeface="Ebrima"/>
       </a:majorFont>
       <a:minorFont>
-        <a:latin typeface="Calibri"/>
+        <a:latin typeface="Aptos" panose="02110004020202020204"/>
         <a:ea typeface=""/>
         <a:cs typeface=""/>
-        <a:font script="Jpan" typeface="ＭＳ Ｐゴシック"/>
+        <a:font script="Jpan" typeface="游ゴシック"/>
         <a:font script="Hang" typeface="맑은 고딕"/>
-        <a:font script="Hans" typeface="宋体"/>
+        <a:font script="Hans" typeface="等线"/>
         <a:font script="Hant" typeface="新細明體"/>
         <a:font script="Arab" typeface="Arial"/>
         <a:font script="Hebr" typeface="Arial"/>
@@ -6967,6 +8269,23 @@
         <a:font script="Viet" typeface="Arial"/>
         <a:font script="Uigh" typeface="Microsoft Uighur"/>
         <a:font script="Geor" typeface="Sylfaen"/>
+        <a:font script="Armn" typeface="Arial"/>
+        <a:font script="Bugi" typeface="Leelawadee UI"/>
+        <a:font script="Bopo" typeface="Microsoft JhengHei"/>
+        <a:font script="Java" typeface="Javanese Text"/>
+        <a:font script="Lisu" typeface="Segoe UI"/>
+        <a:font script="Mymr" typeface="Myanmar Text"/>
+        <a:font script="Nkoo" typeface="Ebrima"/>
+        <a:font script="Olck" typeface="Nirmala UI"/>
+        <a:font script="Osma" typeface="Ebrima"/>
+        <a:font script="Phag" typeface="Phagspa"/>
+        <a:font script="Syrn" typeface="Estrangelo Edessa"/>
+        <a:font script="Syrj" typeface="Estrangelo Edessa"/>
+        <a:font script="Syre" typeface="Estrangelo Edessa"/>
+        <a:font script="Sora" typeface="Nirmala UI"/>
+        <a:font script="Tale" typeface="Microsoft Tai Le"/>
+        <a:font script="Talu" typeface="Microsoft New Tai Lue"/>
+        <a:font script="Tfng" typeface="Ebrima"/>
       </a:minorFont>
     </a:fontScheme>
     <a:fmtScheme name="Office">
@@ -6978,180 +8297,136 @@
           <a:gsLst>
             <a:gs pos="0">
               <a:schemeClr val="phClr">
-                <a:tint val="50000"/>
-                <a:satMod val="300000"/>
+                <a:lumMod val="110000"/>
+                <a:satMod val="105000"/>
+                <a:tint val="67000"/>
               </a:schemeClr>
             </a:gs>
-            <a:gs pos="35000">
+            <a:gs pos="50000">
               <a:schemeClr val="phClr">
-                <a:tint val="37000"/>
-                <a:satMod val="300000"/>
+                <a:lumMod val="105000"/>
+                <a:satMod val="103000"/>
+                <a:tint val="73000"/>
               </a:schemeClr>
             </a:gs>
             <a:gs pos="100000">
               <a:schemeClr val="phClr">
-                <a:tint val="15000"/>
-                <a:satMod val="350000"/>
+                <a:lumMod val="105000"/>
+                <a:satMod val="109000"/>
+                <a:tint val="81000"/>
               </a:schemeClr>
             </a:gs>
           </a:gsLst>
-          <a:lin ang="16200000" scaled="1"/>
+          <a:lin ang="5400000" scaled="0"/>
         </a:gradFill>
         <a:gradFill rotWithShape="1">
           <a:gsLst>
             <a:gs pos="0">
               <a:schemeClr val="phClr">
-                <a:tint val="100000"/>
+                <a:satMod val="103000"/>
+                <a:lumMod val="102000"/>
+                <a:tint val="94000"/>
+              </a:schemeClr>
+            </a:gs>
+            <a:gs pos="50000">
+              <a:schemeClr val="phClr">
+                <a:satMod val="110000"/>
+                <a:lumMod val="100000"/>
                 <a:shade val="100000"/>
-                <a:satMod val="130000"/>
               </a:schemeClr>
             </a:gs>
             <a:gs pos="100000">
               <a:schemeClr val="phClr">
-                <a:tint val="50000"/>
-                <a:shade val="100000"/>
-                <a:satMod val="350000"/>
+                <a:lumMod val="99000"/>
+                <a:satMod val="120000"/>
+                <a:shade val="78000"/>
               </a:schemeClr>
             </a:gs>
           </a:gsLst>
-          <a:lin ang="16200000" scaled="0"/>
+          <a:lin ang="5400000" scaled="0"/>
         </a:gradFill>
       </a:fillStyleLst>
       <a:lnStyleLst>
-        <a:ln w="9525" cap="flat" cmpd="sng" algn="ctr">
+        <a:ln w="12700" cap="flat" cmpd="sng" algn="ctr">
           <a:solidFill>
-            <a:schemeClr val="phClr">
-              <a:shade val="95000"/>
-              <a:satMod val="105000"/>
-            </a:schemeClr>
+            <a:schemeClr val="phClr"/>
           </a:solidFill>
           <a:prstDash val="solid"/>
+          <a:miter lim="800000"/>
+        </a:ln>
+        <a:ln w="19050" cap="flat" cmpd="sng" algn="ctr">
+          <a:solidFill>
+            <a:schemeClr val="phClr"/>
+          </a:solidFill>
+          <a:prstDash val="solid"/>
+          <a:miter lim="800000"/>
         </a:ln>
         <a:ln w="25400" cap="flat" cmpd="sng" algn="ctr">
           <a:solidFill>
             <a:schemeClr val="phClr"/>
           </a:solidFill>
           <a:prstDash val="solid"/>
-        </a:ln>
-        <a:ln w="38100" cap="flat" cmpd="sng" algn="ctr">
-          <a:solidFill>
-            <a:schemeClr val="phClr"/>
-          </a:solidFill>
-          <a:prstDash val="solid"/>
+          <a:miter lim="800000"/>
         </a:ln>
       </a:lnStyleLst>
       <a:effectStyleLst>
         <a:effectStyle>
+          <a:effectLst/>
+        </a:effectStyle>
+        <a:effectStyle>
+          <a:effectLst/>
+        </a:effectStyle>
+        <a:effectStyle>
           <a:effectLst>
-            <a:outerShdw blurRad="40000" dist="20000" dir="5400000" rotWithShape="0">
+            <a:outerShdw blurRad="57150" dist="19050" dir="5400000" algn="ctr" rotWithShape="0">
               <a:srgbClr val="000000">
-                <a:alpha val="38000"/>
+                <a:alpha val="63000"/>
               </a:srgbClr>
             </a:outerShdw>
           </a:effectLst>
-        </a:effectStyle>
-        <a:effectStyle>
-          <a:effectLst>
-            <a:outerShdw blurRad="40000" dist="23000" dir="5400000" rotWithShape="0">
-              <a:srgbClr val="000000">
-                <a:alpha val="35000"/>
-              </a:srgbClr>
-            </a:outerShdw>
-          </a:effectLst>
-        </a:effectStyle>
-        <a:effectStyle>
-          <a:effectLst>
-            <a:outerShdw blurRad="40000" dist="23000" dir="5400000" rotWithShape="0">
-              <a:srgbClr val="000000">
-                <a:alpha val="35000"/>
-              </a:srgbClr>
-            </a:outerShdw>
-          </a:effectLst>
-          <a:scene3d>
-            <a:camera prst="orthographicFront">
-              <a:rot lat="0" lon="0" rev="0"/>
-            </a:camera>
-            <a:lightRig rig="threePt" dir="t">
-              <a:rot lat="0" lon="0" rev="1200000"/>
-            </a:lightRig>
-          </a:scene3d>
-          <a:sp3d>
-            <a:bevelT w="63500" h="25400"/>
-          </a:sp3d>
         </a:effectStyle>
       </a:effectStyleLst>
       <a:bgFillStyleLst>
         <a:solidFill>
           <a:schemeClr val="phClr"/>
         </a:solidFill>
+        <a:solidFill>
+          <a:schemeClr val="phClr">
+            <a:tint val="95000"/>
+            <a:satMod val="170000"/>
+          </a:schemeClr>
+        </a:solidFill>
         <a:gradFill rotWithShape="1">
           <a:gsLst>
             <a:gs pos="0">
               <a:schemeClr val="phClr">
-                <a:tint val="40000"/>
-                <a:satMod val="350000"/>
+                <a:tint val="93000"/>
+                <a:satMod val="150000"/>
+                <a:shade val="98000"/>
+                <a:lumMod val="102000"/>
               </a:schemeClr>
             </a:gs>
-            <a:gs pos="40000">
+            <a:gs pos="50000">
               <a:schemeClr val="phClr">
-                <a:tint val="45000"/>
-                <a:shade val="99000"/>
-                <a:satMod val="350000"/>
+                <a:tint val="98000"/>
+                <a:satMod val="130000"/>
+                <a:shade val="90000"/>
+                <a:lumMod val="103000"/>
               </a:schemeClr>
             </a:gs>
             <a:gs pos="100000">
               <a:schemeClr val="phClr">
-                <a:shade val="20000"/>
-                <a:satMod val="255000"/>
+                <a:shade val="63000"/>
+                <a:satMod val="120000"/>
               </a:schemeClr>
             </a:gs>
           </a:gsLst>
-          <a:path path="circle">
-            <a:fillToRect l="50000" t="-80000" r="50000" b="180000"/>
-          </a:path>
-        </a:gradFill>
-        <a:gradFill rotWithShape="1">
-          <a:gsLst>
-            <a:gs pos="0">
-              <a:schemeClr val="phClr">
-                <a:tint val="80000"/>
-                <a:satMod val="300000"/>
-              </a:schemeClr>
-            </a:gs>
-            <a:gs pos="100000">
-              <a:schemeClr val="phClr">
-                <a:shade val="30000"/>
-                <a:satMod val="200000"/>
-              </a:schemeClr>
-            </a:gs>
-          </a:gsLst>
-          <a:path path="circle">
-            <a:fillToRect l="50000" t="50000" r="50000" b="50000"/>
-          </a:path>
+          <a:lin ang="5400000" scaled="0"/>
         </a:gradFill>
       </a:bgFillStyleLst>
     </a:fmtScheme>
   </a:themeElements>
   <a:objectDefaults>
-    <a:spDef>
-      <a:spPr/>
-      <a:bodyPr/>
-      <a:lstStyle/>
-      <a:style>
-        <a:lnRef idx="1">
-          <a:schemeClr val="accent1"/>
-        </a:lnRef>
-        <a:fillRef idx="3">
-          <a:schemeClr val="accent1"/>
-        </a:fillRef>
-        <a:effectRef idx="2">
-          <a:schemeClr val="accent1"/>
-        </a:effectRef>
-        <a:fontRef idx="minor">
-          <a:schemeClr val="lt1"/>
-        </a:fontRef>
-      </a:style>
-    </a:spDef>
     <a:lnDef>
       <a:spPr/>
       <a:bodyPr/>
@@ -7173,5 +8448,10 @@
     </a:lnDef>
   </a:objectDefaults>
   <a:extraClrSchemeLst/>
+  <a:extLst>
+    <a:ext uri="{05A4C25C-085E-4340-85A3-A5531E510DB2}">
+      <thm15:themeFamily xmlns:thm15="http://schemas.microsoft.com/office/thememl/2012/main" name="Office Theme" id="{2E142A2C-CD16-42D6-873A-C26D2A0506FA}" vid="{1BDDFF52-6CD6-40A5-AB3C-68EB2F1E4D0A}"/>
+    </a:ext>
+  </a:extLst>
 </a:theme>
 </file>
</xml_diff>